<commit_message>
Diapositivas en blanco y negro firmadas por el docente
Cambia la paleta del tema a escala de grises, añade la firma «Mg. Carlos Arturo Ramos Mejía - Prof. Cátedra UFPS» al pie de todas las láminas y a la portada, y ajusta el color del texto de insignias y pirámide según la luminancia del fondo.

Co-Authored-By: Claude Fable 5.1 <noreply@anthropic.com>
Claude-Session: https://claude.ai/code/session_01EAyYbF3cABYpsZz5RGkS7F
</commit_message>
<xml_diff>
--- a/clase-derecho-informatico/DIAPOSITIVAS.pptx
+++ b/clase-derecho-informatico/DIAPOSITIVAS.pptx
@@ -130,14 +130,14 @@
   <p:extLst>
     <p:ext uri="{521415D9-36F7-43E2-AB2F-B90AF26B5E84}">
       <p14:sectionLst xmlns:p14="http://schemas.microsoft.com/office/powerpoint/2010/main">
-        <p14:section name="Apertura" id="{e798f34e-1cc3-b37e-9339-23129d4c00a9}">
+        <p14:section name="Apertura" id="{8ebf6190-fec8-587f-9c60-f0c53608afb0}">
           <p14:sldIdLst>
             <p14:sldId id="256"/>
             <p14:sldId id="257"/>
             <p14:sldId id="258"/>
           </p14:sldIdLst>
         </p14:section>
-        <p14:section name="Fundamentos" id="{e1f5e89c-232e-0b27-78fe-5addc0a56d85}">
+        <p14:section name="Fundamentos" id="{ee72d9fb-da6a-7002-7fb7-7f0b303a283b}">
           <p14:sldIdLst>
             <p14:sldId id="259"/>
             <p14:sldId id="260"/>
@@ -145,7 +145,7 @@
             <p14:sldId id="262"/>
           </p14:sldIdLst>
         </p14:section>
-        <p14:section name="Evolución, objeto y fuentes" id="{36aebf38-502f-956b-a4d4-67f66a9e2356}">
+        <p14:section name="Evolución, objeto y fuentes" id="{1326fe63-540e-0a7e-b8af-4acca1c21c7c}">
           <p14:sldIdLst>
             <p14:sldId id="263"/>
             <p14:sldId id="264"/>
@@ -154,14 +154,14 @@
             <p14:sldId id="267"/>
           </p14:sldIdLst>
         </p14:section>
-        <p14:section name="Principios y campos" id="{c00a6ae9-aef2-6da6-2d41-b59cd9709618}">
+        <p14:section name="Principios y campos" id="{c930bf3d-5770-d293-5e92-2e25a7575f10}">
           <p14:sldIdLst>
             <p14:sldId id="268"/>
             <p14:sldId id="269"/>
             <p14:sldId id="270"/>
           </p14:sldIdLst>
         </p14:section>
-        <p14:section name="Video y sentencia hito" id="{3711ed37-3713-717c-c0d0-c6be6334ae80}">
+        <p14:section name="Video y sentencia hito" id="{51db9366-6d14-0606-fdf2-934fc37f28b6}">
           <p14:sldIdLst>
             <p14:sldId id="271"/>
             <p14:sldId id="272"/>
@@ -170,7 +170,7 @@
             <p14:sldId id="275"/>
           </p14:sldIdLst>
         </p14:section>
-        <p14:section name="Aplicación y cierre" id="{e834ead2-ba0f-9168-7d21-bf124ca2ced3}">
+        <p14:section name="Aplicación y cierre" id="{65a2a38c-d5aa-3c36-cd99-12b0a336991b}">
           <p14:sldIdLst>
             <p14:sldId id="276"/>
             <p14:sldId id="277"/>
@@ -2684,7 +2684,7 @@
     <p:bg>
       <p:bgPr>
         <a:solidFill>
-          <a:srgbClr val="1B1F2E"/>
+          <a:srgbClr val="000000"/>
         </a:solidFill>
       </p:bgPr>
     </p:bg>
@@ -2750,7 +2750,7 @@
         <p:spPr>
           <a:xfrm>
             <a:off x="548640" y="6400800"/>
-            <a:ext cx="7315200" cy="274320"/>
+            <a:ext cx="9875520" cy="274320"/>
           </a:xfrm>
           <a:prstGeom prst="rect">
             <a:avLst/>
@@ -2771,7 +2771,7 @@
                   <a:schemeClr val="accent6"/>
                 </a:solidFill>
               </a:rPr>
-              <a:t>Tecnología y Derecho · Derecho Informático · UFPS</a:t>
+              <a:t>Mg. Carlos Arturo Ramos Mejía - Prof. Cátedra UFPS · Tecnología y Derecho · Derecho Informático</a:t>
             </a:r>
             <a:endParaRPr lang="en-US" sz="1000" dirty="0"/>
           </a:p>
@@ -2807,7 +2807,7 @@
             <a:lvl1pPr>
               <a:defRPr sz="1000">
                 <a:solidFill>
-                  <a:srgbClr val="9BA7B4"/>
+                  <a:srgbClr val="BFBFBF"/>
                 </a:solidFill>
               </a:defRPr>
             </a:lvl1pPr>
@@ -2902,7 +2902,7 @@
         <p:spPr>
           <a:xfrm>
             <a:off x="548640" y="6400800"/>
-            <a:ext cx="7315200" cy="274320"/>
+            <a:ext cx="9875520" cy="274320"/>
           </a:xfrm>
           <a:prstGeom prst="rect">
             <a:avLst/>
@@ -2923,7 +2923,7 @@
                   <a:schemeClr val="accent5"/>
                 </a:solidFill>
               </a:rPr>
-              <a:t>Tecnología y Derecho · Derecho Informático · UFPS</a:t>
+              <a:t>Mg. Carlos Arturo Ramos Mejía - Prof. Cátedra UFPS · Tecnología y Derecho · Derecho Informático</a:t>
             </a:r>
             <a:endParaRPr lang="en-US" sz="1000" dirty="0"/>
           </a:p>
@@ -2959,7 +2959,7 @@
             <a:lvl1pPr>
               <a:defRPr sz="1000">
                 <a:solidFill>
-                  <a:srgbClr val="4A6670"/>
+                  <a:srgbClr val="595959"/>
                 </a:solidFill>
               </a:defRPr>
             </a:lvl1pPr>
@@ -2988,7 +2988,7 @@
     <p:bg>
       <p:bgPr>
         <a:solidFill>
-          <a:srgbClr val="1B1F2E"/>
+          <a:srgbClr val="000000"/>
         </a:solidFill>
       </p:bgPr>
     </p:bg>
@@ -3081,6 +3081,42 @@
               <a:buNone/>
             </a:pPr>
             <a:endParaRPr lang="en-US" sz="2000" dirty="0"/>
+          </a:p>
+        </p:txBody>
+      </p:sp>
+      <p:sp>
+        <p:nvSpPr>
+          <p:cNvPr id="4" name="Text 0"/>
+          <p:cNvSpPr txBox="1"/>
+          <p:nvPr/>
+        </p:nvSpPr>
+        <p:spPr>
+          <a:xfrm>
+            <a:off x="548640" y="6400800"/>
+            <a:ext cx="9875520" cy="274320"/>
+          </a:xfrm>
+          <a:prstGeom prst="rect">
+            <a:avLst/>
+          </a:prstGeom>
+          <a:noFill/>
+          <a:ln/>
+        </p:spPr>
+        <p:txBody>
+          <a:bodyPr wrap="square" lIns="0" tIns="0" rIns="0" bIns="0" rtlCol="0" anchor="ctr"/>
+          <a:lstStyle/>
+          <a:p>
+            <a:pPr indent="0" marL="0">
+              <a:buNone/>
+            </a:pPr>
+            <a:r>
+              <a:rPr lang="en-US" sz="1000" dirty="0">
+                <a:solidFill>
+                  <a:schemeClr val="accent6"/>
+                </a:solidFill>
+              </a:rPr>
+              <a:t>Mg. Carlos Arturo Ramos Mejía - Prof. Cátedra UFPS · Tecnología y Derecho · Derecho Informático</a:t>
+            </a:r>
+            <a:endParaRPr lang="en-US" sz="1000" dirty="0"/>
           </a:p>
         </p:txBody>
       </p:sp>
@@ -3139,7 +3175,7 @@
             <a:lvl1pPr>
               <a:defRPr sz="1000">
                 <a:solidFill>
-                  <a:srgbClr val="9BA7B4"/>
+                  <a:srgbClr val="BFBFBF"/>
                 </a:solidFill>
               </a:defRPr>
             </a:lvl1pPr>
@@ -3532,7 +3568,7 @@
                   <a:schemeClr val="accent6"/>
                 </a:solidFill>
               </a:rPr>
-              <a:t>Docente: Carlos Arturo Ramos Mejía · 2026</a:t>
+              <a:t>Mg. Carlos Arturo Ramos Mejía - Prof. Cátedra UFPS · 2026</a:t>
             </a:r>
             <a:endParaRPr lang="en-US" sz="2000" dirty="0"/>
           </a:p>
@@ -3553,11 +3589,11 @@
             <a:avLst/>
           </a:prstGeom>
           <a:solidFill>
-            <a:srgbClr val="0E7C86"/>
+            <a:srgbClr val="404040"/>
           </a:solidFill>
           <a:ln w="12700">
             <a:solidFill>
-              <a:srgbClr val="0E7C86"/>
+              <a:srgbClr val="404040"/>
             </a:solidFill>
             <a:prstDash val="solid"/>
           </a:ln>
@@ -3703,11 +3739,11 @@
             </a:avLst>
           </a:prstGeom>
           <a:solidFill>
-            <a:srgbClr val="1F3A5F"/>
+            <a:srgbClr val="333333"/>
           </a:solidFill>
           <a:ln w="12700">
             <a:solidFill>
-              <a:srgbClr val="1F3A5F"/>
+              <a:srgbClr val="333333"/>
             </a:solidFill>
             <a:prstDash val="solid"/>
           </a:ln>
@@ -3728,11 +3764,11 @@
             <a:avLst/>
           </a:prstGeom>
           <a:solidFill>
-            <a:srgbClr val="D9931D"/>
+            <a:srgbClr val="A6A6A6"/>
           </a:solidFill>
           <a:ln w="12700">
             <a:solidFill>
-              <a:srgbClr val="D9931D"/>
+              <a:srgbClr val="A6A6A6"/>
             </a:solidFill>
             <a:prstDash val="solid"/>
           </a:ln>
@@ -3887,11 +3923,11 @@
             </a:avLst>
           </a:prstGeom>
           <a:solidFill>
-            <a:srgbClr val="1F3A5F"/>
+            <a:srgbClr val="333333"/>
           </a:solidFill>
           <a:ln w="12700">
             <a:solidFill>
-              <a:srgbClr val="1F3A5F"/>
+              <a:srgbClr val="333333"/>
             </a:solidFill>
             <a:prstDash val="solid"/>
           </a:ln>
@@ -3912,11 +3948,11 @@
             <a:avLst/>
           </a:prstGeom>
           <a:solidFill>
-            <a:srgbClr val="D9931D"/>
+            <a:srgbClr val="A6A6A6"/>
           </a:solidFill>
           <a:ln w="12700">
             <a:solidFill>
-              <a:srgbClr val="D9931D"/>
+              <a:srgbClr val="A6A6A6"/>
             </a:solidFill>
             <a:prstDash val="solid"/>
           </a:ln>
@@ -4071,11 +4107,11 @@
             </a:avLst>
           </a:prstGeom>
           <a:solidFill>
-            <a:srgbClr val="1F3A5F"/>
+            <a:srgbClr val="333333"/>
           </a:solidFill>
           <a:ln w="12700">
             <a:solidFill>
-              <a:srgbClr val="1F3A5F"/>
+              <a:srgbClr val="333333"/>
             </a:solidFill>
             <a:prstDash val="solid"/>
           </a:ln>
@@ -4096,11 +4132,11 @@
             <a:avLst/>
           </a:prstGeom>
           <a:solidFill>
-            <a:srgbClr val="D9931D"/>
+            <a:srgbClr val="A6A6A6"/>
           </a:solidFill>
           <a:ln w="12700">
             <a:solidFill>
-              <a:srgbClr val="D9931D"/>
+              <a:srgbClr val="A6A6A6"/>
             </a:solidFill>
             <a:prstDash val="solid"/>
           </a:ln>
@@ -4255,11 +4291,11 @@
             </a:avLst>
           </a:prstGeom>
           <a:solidFill>
-            <a:srgbClr val="0E7C86"/>
+            <a:srgbClr val="404040"/>
           </a:solidFill>
           <a:ln w="12700">
             <a:solidFill>
-              <a:srgbClr val="0E7C86"/>
+              <a:srgbClr val="404040"/>
             </a:solidFill>
             <a:prstDash val="solid"/>
           </a:ln>
@@ -4331,7 +4367,7 @@
             <a:lvl1pPr>
               <a:defRPr sz="1000">
                 <a:solidFill>
-                  <a:srgbClr val="9BA7B4"/>
+                  <a:srgbClr val="BFBFBF"/>
                 </a:solidFill>
               </a:defRPr>
             </a:lvl1pPr>
@@ -4424,7 +4460,7 @@
             <a:avLst/>
           </a:prstGeom>
           <a:solidFill>
-            <a:srgbClr val="1F3A5F"/>
+            <a:srgbClr val="333333"/>
           </a:solidFill>
           <a:ln w="12700">
             <a:solidFill>
@@ -4461,7 +4497,7 @@
             <a:r>
               <a:rPr lang="en-US" sz="1400" b="1" dirty="0">
                 <a:solidFill>
-                  <a:schemeClr val="bg1"/>
+                  <a:srgbClr val="FFFFFF"/>
                 </a:solidFill>
               </a:rPr>
               <a:t>Constitución  </a:t>
@@ -4472,7 +4508,7 @@
             <a:r>
               <a:rPr lang="en-US" sz="1150" dirty="0">
                 <a:solidFill>
-                  <a:schemeClr val="bg1"/>
+                  <a:srgbClr val="FFFFFF"/>
                 </a:solidFill>
               </a:rPr>
               <a:t>Arts. 15, 20, 61, 74</a:t>
@@ -4496,7 +4532,7 @@
             <a:avLst/>
           </a:prstGeom>
           <a:solidFill>
-            <a:srgbClr val="4A6670"/>
+            <a:srgbClr val="595959"/>
           </a:solidFill>
           <a:ln w="12700">
             <a:solidFill>
@@ -4533,7 +4569,7 @@
             <a:r>
               <a:rPr lang="en-US" sz="1400" b="1" dirty="0">
                 <a:solidFill>
-                  <a:schemeClr val="bg1"/>
+                  <a:srgbClr val="FFFFFF"/>
                 </a:solidFill>
               </a:rPr>
               <a:t>Tratados y soft law  </a:t>
@@ -4544,7 +4580,7 @@
             <a:r>
               <a:rPr lang="en-US" sz="1150" dirty="0">
                 <a:solidFill>
-                  <a:schemeClr val="bg1"/>
+                  <a:srgbClr val="FFFFFF"/>
                 </a:solidFill>
               </a:rPr>
               <a:t>Convenio de Budapest (Ley 1928 de 2018); Convenio 108; Recomendación UNESCO sobre IA (2021); principios OCDE (2019)</a:t>
@@ -4568,7 +4604,7 @@
             <a:avLst/>
           </a:prstGeom>
           <a:solidFill>
-            <a:srgbClr val="0E7C86"/>
+            <a:srgbClr val="404040"/>
           </a:solidFill>
           <a:ln w="12700">
             <a:solidFill>
@@ -4605,7 +4641,7 @@
             <a:r>
               <a:rPr lang="en-US" sz="1400" b="1" dirty="0">
                 <a:solidFill>
-                  <a:schemeClr val="bg1"/>
+                  <a:srgbClr val="FFFFFF"/>
                 </a:solidFill>
               </a:rPr>
               <a:t>Leyes estatutarias  </a:t>
@@ -4616,7 +4652,7 @@
             <a:r>
               <a:rPr lang="en-US" sz="1150" dirty="0">
                 <a:solidFill>
-                  <a:schemeClr val="bg1"/>
+                  <a:srgbClr val="FFFFFF"/>
                 </a:solidFill>
               </a:rPr>
               <a:t>Ley 1266 de 2008; Ley 1581 de 2012; Ley 1712 de 2014</a:t>
@@ -4640,7 +4676,7 @@
             <a:avLst/>
           </a:prstGeom>
           <a:solidFill>
-            <a:srgbClr val="5B7DB1"/>
+            <a:srgbClr val="737373"/>
           </a:solidFill>
           <a:ln w="12700">
             <a:solidFill>
@@ -4677,7 +4713,7 @@
             <a:r>
               <a:rPr lang="en-US" sz="1400" b="1" dirty="0">
                 <a:solidFill>
-                  <a:schemeClr val="bg1"/>
+                  <a:srgbClr val="FFFFFF"/>
                 </a:solidFill>
               </a:rPr>
               <a:t>Leyes ordinarias  </a:t>
@@ -4688,7 +4724,7 @@
             <a:r>
               <a:rPr lang="en-US" sz="1150" dirty="0">
                 <a:solidFill>
-                  <a:schemeClr val="bg1"/>
+                  <a:srgbClr val="FFFFFF"/>
                 </a:solidFill>
               </a:rPr>
               <a:t>Ley 527 de 1999; Ley 1273 de 2009; Ley 1341 de 2009; Ley 2213 de 2022</a:t>
@@ -4712,7 +4748,7 @@
             <a:avLst/>
           </a:prstGeom>
           <a:solidFill>
-            <a:srgbClr val="D9931D"/>
+            <a:srgbClr val="A6A6A6"/>
           </a:solidFill>
           <a:ln w="12700">
             <a:solidFill>
@@ -4749,7 +4785,7 @@
             <a:r>
               <a:rPr lang="en-US" sz="1400" b="1" dirty="0">
                 <a:solidFill>
-                  <a:schemeClr val="bg1"/>
+                  <a:srgbClr val="000000"/>
                 </a:solidFill>
               </a:rPr>
               <a:t>Reglamentos y regulación  </a:t>
@@ -4760,7 +4796,7 @@
             <a:r>
               <a:rPr lang="en-US" sz="1150" dirty="0">
                 <a:solidFill>
-                  <a:schemeClr val="bg1"/>
+                  <a:srgbClr val="000000"/>
                 </a:solidFill>
               </a:rPr>
               <a:t>Decretos 1377 de 2013 y 1074 de 2015; circulares de la SIC (002 de 2024); resoluciones CRC</a:t>
@@ -4784,7 +4820,7 @@
             <a:avLst/>
           </a:prstGeom>
           <a:solidFill>
-            <a:srgbClr val="B5413F"/>
+            <a:srgbClr val="4D4D4D"/>
           </a:solidFill>
           <a:ln w="12700">
             <a:solidFill>
@@ -4821,7 +4857,7 @@
             <a:r>
               <a:rPr lang="en-US" sz="1400" b="1" dirty="0">
                 <a:solidFill>
-                  <a:schemeClr val="bg1"/>
+                  <a:srgbClr val="FFFFFF"/>
                 </a:solidFill>
               </a:rPr>
               <a:t>Jurisprudencia  </a:t>
@@ -4832,7 +4868,7 @@
             <a:r>
               <a:rPr lang="en-US" sz="1150" dirty="0">
                 <a:solidFill>
-                  <a:schemeClr val="bg1"/>
+                  <a:srgbClr val="FFFFFF"/>
                 </a:solidFill>
               </a:rPr>
               <a:t>T-414 de 1992; SU-082 de 1995; C-748 de 2011; T-323 de 2024; STC17832-2025; AC739-2026</a:t>
@@ -4856,7 +4892,7 @@
             <a:avLst/>
           </a:prstGeom>
           <a:solidFill>
-            <a:srgbClr val="9BA7B4"/>
+            <a:srgbClr val="BFBFBF"/>
           </a:solidFill>
           <a:ln w="12700">
             <a:solidFill>
@@ -4893,7 +4929,7 @@
             <a:r>
               <a:rPr lang="en-US" sz="1400" b="1" dirty="0">
                 <a:solidFill>
-                  <a:schemeClr val="bg1"/>
+                  <a:srgbClr val="000000"/>
                 </a:solidFill>
               </a:rPr>
               <a:t>Autorregulación y código  </a:t>
@@ -4904,7 +4940,7 @@
             <a:r>
               <a:rPr lang="en-US" sz="1150" dirty="0">
                 <a:solidFill>
-                  <a:schemeClr val="bg1"/>
+                  <a:srgbClr val="000000"/>
                 </a:solidFill>
               </a:rPr>
               <a:t>Políticas de tratamiento, términos de servicio, estándares técnicos: la arquitectura también regula (Lessig)</a:t>
@@ -4943,7 +4979,7 @@
             <a:lvl1pPr>
               <a:defRPr sz="1000">
                 <a:solidFill>
-                  <a:srgbClr val="4A6670"/>
+                  <a:srgbClr val="595959"/>
                 </a:solidFill>
               </a:defRPr>
             </a:lvl1pPr>
@@ -5038,11 +5074,11 @@
             </a:avLst>
           </a:prstGeom>
           <a:solidFill>
-            <a:srgbClr val="EEF3F8"/>
+            <a:srgbClr val="EDEDED"/>
           </a:solidFill>
           <a:ln w="12700">
             <a:solidFill>
-              <a:srgbClr val="EEF3F8"/>
+              <a:srgbClr val="EDEDED"/>
             </a:solidFill>
             <a:prstDash val="solid"/>
           </a:ln>
@@ -5063,11 +5099,11 @@
             <a:avLst/>
           </a:prstGeom>
           <a:solidFill>
-            <a:srgbClr val="0E7C86"/>
+            <a:srgbClr val="404040"/>
           </a:solidFill>
           <a:ln w="12700">
             <a:solidFill>
-              <a:srgbClr val="0E7C86"/>
+              <a:srgbClr val="404040"/>
             </a:solidFill>
             <a:prstDash val="solid"/>
           </a:ln>
@@ -5254,11 +5290,11 @@
             <a:avLst/>
           </a:prstGeom>
           <a:solidFill>
-            <a:srgbClr val="D9931D"/>
+            <a:srgbClr val="A6A6A6"/>
           </a:solidFill>
           <a:ln w="12700">
             <a:solidFill>
-              <a:srgbClr val="D9931D"/>
+              <a:srgbClr val="A6A6A6"/>
             </a:solidFill>
             <a:prstDash val="solid"/>
           </a:ln>
@@ -5291,7 +5327,7 @@
             <a:r>
               <a:rPr lang="en-US" sz="1400" b="1" dirty="0">
                 <a:solidFill>
-                  <a:schemeClr val="bg1"/>
+                  <a:srgbClr val="000000"/>
                 </a:solidFill>
               </a:rPr>
               <a:t>1</a:t>
@@ -5351,11 +5387,11 @@
             <a:avLst/>
           </a:prstGeom>
           <a:solidFill>
-            <a:srgbClr val="D9931D"/>
+            <a:srgbClr val="A6A6A6"/>
           </a:solidFill>
           <a:ln w="12700">
             <a:solidFill>
-              <a:srgbClr val="D9931D"/>
+              <a:srgbClr val="A6A6A6"/>
             </a:solidFill>
             <a:prstDash val="solid"/>
           </a:ln>
@@ -5388,7 +5424,7 @@
             <a:r>
               <a:rPr lang="en-US" sz="1400" b="1" dirty="0">
                 <a:solidFill>
-                  <a:schemeClr val="bg1"/>
+                  <a:srgbClr val="000000"/>
                 </a:solidFill>
               </a:rPr>
               <a:t>2</a:t>
@@ -5448,11 +5484,11 @@
             <a:avLst/>
           </a:prstGeom>
           <a:solidFill>
-            <a:srgbClr val="D9931D"/>
+            <a:srgbClr val="A6A6A6"/>
           </a:solidFill>
           <a:ln w="12700">
             <a:solidFill>
-              <a:srgbClr val="D9931D"/>
+              <a:srgbClr val="A6A6A6"/>
             </a:solidFill>
             <a:prstDash val="solid"/>
           </a:ln>
@@ -5485,7 +5521,7 @@
             <a:r>
               <a:rPr lang="en-US" sz="1400" b="1" dirty="0">
                 <a:solidFill>
-                  <a:schemeClr val="bg1"/>
+                  <a:srgbClr val="000000"/>
                 </a:solidFill>
               </a:rPr>
               <a:t>3</a:t>
@@ -5547,11 +5583,11 @@
             </a:avLst>
           </a:prstGeom>
           <a:solidFill>
-            <a:srgbClr val="1F3A5F"/>
+            <a:srgbClr val="333333"/>
           </a:solidFill>
           <a:ln w="12700">
             <a:solidFill>
-              <a:srgbClr val="1F3A5F"/>
+              <a:srgbClr val="333333"/>
             </a:solidFill>
             <a:prstDash val="solid"/>
           </a:ln>
@@ -5634,7 +5670,7 @@
             <a:lvl1pPr>
               <a:defRPr sz="1000">
                 <a:solidFill>
-                  <a:srgbClr val="4A6670"/>
+                  <a:srgbClr val="595959"/>
                 </a:solidFill>
               </a:defRPr>
             </a:lvl1pPr>
@@ -5727,11 +5763,11 @@
             <a:avLst/>
           </a:prstGeom>
           <a:solidFill>
-            <a:srgbClr val="0E7C86"/>
+            <a:srgbClr val="404040"/>
           </a:solidFill>
           <a:ln w="12700">
             <a:solidFill>
-              <a:srgbClr val="0E7C86"/>
+              <a:srgbClr val="404040"/>
             </a:solidFill>
             <a:prstDash val="solid"/>
           </a:ln>
@@ -5826,11 +5862,11 @@
             <a:avLst/>
           </a:prstGeom>
           <a:solidFill>
-            <a:srgbClr val="0E7C86"/>
+            <a:srgbClr val="404040"/>
           </a:solidFill>
           <a:ln w="12700">
             <a:solidFill>
-              <a:srgbClr val="0E7C86"/>
+              <a:srgbClr val="404040"/>
             </a:solidFill>
             <a:prstDash val="solid"/>
           </a:ln>
@@ -5925,11 +5961,11 @@
             <a:avLst/>
           </a:prstGeom>
           <a:solidFill>
-            <a:srgbClr val="0E7C86"/>
+            <a:srgbClr val="404040"/>
           </a:solidFill>
           <a:ln w="12700">
             <a:solidFill>
-              <a:srgbClr val="0E7C86"/>
+              <a:srgbClr val="404040"/>
             </a:solidFill>
             <a:prstDash val="solid"/>
           </a:ln>
@@ -6024,11 +6060,11 @@
             <a:avLst/>
           </a:prstGeom>
           <a:solidFill>
-            <a:srgbClr val="0E7C86"/>
+            <a:srgbClr val="404040"/>
           </a:solidFill>
           <a:ln w="12700">
             <a:solidFill>
-              <a:srgbClr val="0E7C86"/>
+              <a:srgbClr val="404040"/>
             </a:solidFill>
             <a:prstDash val="solid"/>
           </a:ln>
@@ -6123,11 +6159,11 @@
             <a:avLst/>
           </a:prstGeom>
           <a:solidFill>
-            <a:srgbClr val="0E7C86"/>
+            <a:srgbClr val="404040"/>
           </a:solidFill>
           <a:ln w="12700">
             <a:solidFill>
-              <a:srgbClr val="0E7C86"/>
+              <a:srgbClr val="404040"/>
             </a:solidFill>
             <a:prstDash val="solid"/>
           </a:ln>
@@ -6222,11 +6258,11 @@
             <a:avLst/>
           </a:prstGeom>
           <a:solidFill>
-            <a:srgbClr val="0E7C86"/>
+            <a:srgbClr val="404040"/>
           </a:solidFill>
           <a:ln w="12700">
             <a:solidFill>
-              <a:srgbClr val="0E7C86"/>
+              <a:srgbClr val="404040"/>
             </a:solidFill>
             <a:prstDash val="solid"/>
           </a:ln>
@@ -6321,11 +6357,11 @@
             <a:avLst/>
           </a:prstGeom>
           <a:solidFill>
-            <a:srgbClr val="0E7C86"/>
+            <a:srgbClr val="404040"/>
           </a:solidFill>
           <a:ln w="12700">
             <a:solidFill>
-              <a:srgbClr val="0E7C86"/>
+              <a:srgbClr val="404040"/>
             </a:solidFill>
             <a:prstDash val="solid"/>
           </a:ln>
@@ -6435,7 +6471,7 @@
             <a:lvl1pPr>
               <a:defRPr sz="1000">
                 <a:solidFill>
-                  <a:srgbClr val="4A6670"/>
+                  <a:srgbClr val="595959"/>
                 </a:solidFill>
               </a:defRPr>
             </a:lvl1pPr>
@@ -6530,11 +6566,11 @@
             </a:avLst>
           </a:prstGeom>
           <a:solidFill>
-            <a:srgbClr val="1F3A5F"/>
+            <a:srgbClr val="333333"/>
           </a:solidFill>
           <a:ln w="12700">
             <a:solidFill>
-              <a:srgbClr val="1F3A5F"/>
+              <a:srgbClr val="333333"/>
             </a:solidFill>
             <a:prstDash val="solid"/>
           </a:ln>
@@ -6555,11 +6591,11 @@
             <a:avLst/>
           </a:prstGeom>
           <a:solidFill>
-            <a:srgbClr val="D9931D"/>
+            <a:srgbClr val="A6A6A6"/>
           </a:solidFill>
           <a:ln w="12700">
             <a:solidFill>
-              <a:srgbClr val="D9931D"/>
+              <a:srgbClr val="A6A6A6"/>
             </a:solidFill>
             <a:prstDash val="solid"/>
           </a:ln>
@@ -6678,11 +6714,11 @@
             </a:avLst>
           </a:prstGeom>
           <a:solidFill>
-            <a:srgbClr val="1F3A5F"/>
+            <a:srgbClr val="333333"/>
           </a:solidFill>
           <a:ln w="12700">
             <a:solidFill>
-              <a:srgbClr val="1F3A5F"/>
+              <a:srgbClr val="333333"/>
             </a:solidFill>
             <a:prstDash val="solid"/>
           </a:ln>
@@ -6703,11 +6739,11 @@
             <a:avLst/>
           </a:prstGeom>
           <a:solidFill>
-            <a:srgbClr val="D9931D"/>
+            <a:srgbClr val="A6A6A6"/>
           </a:solidFill>
           <a:ln w="12700">
             <a:solidFill>
-              <a:srgbClr val="D9931D"/>
+              <a:srgbClr val="A6A6A6"/>
             </a:solidFill>
             <a:prstDash val="solid"/>
           </a:ln>
@@ -6826,11 +6862,11 @@
             </a:avLst>
           </a:prstGeom>
           <a:solidFill>
-            <a:srgbClr val="1F3A5F"/>
+            <a:srgbClr val="333333"/>
           </a:solidFill>
           <a:ln w="12700">
             <a:solidFill>
-              <a:srgbClr val="1F3A5F"/>
+              <a:srgbClr val="333333"/>
             </a:solidFill>
             <a:prstDash val="solid"/>
           </a:ln>
@@ -6851,11 +6887,11 @@
             <a:avLst/>
           </a:prstGeom>
           <a:solidFill>
-            <a:srgbClr val="D9931D"/>
+            <a:srgbClr val="A6A6A6"/>
           </a:solidFill>
           <a:ln w="12700">
             <a:solidFill>
-              <a:srgbClr val="D9931D"/>
+              <a:srgbClr val="A6A6A6"/>
             </a:solidFill>
             <a:prstDash val="solid"/>
           </a:ln>
@@ -6974,11 +7010,11 @@
             </a:avLst>
           </a:prstGeom>
           <a:solidFill>
-            <a:srgbClr val="1F3A5F"/>
+            <a:srgbClr val="333333"/>
           </a:solidFill>
           <a:ln w="12700">
             <a:solidFill>
-              <a:srgbClr val="1F3A5F"/>
+              <a:srgbClr val="333333"/>
             </a:solidFill>
             <a:prstDash val="solid"/>
           </a:ln>
@@ -6999,11 +7035,11 @@
             <a:avLst/>
           </a:prstGeom>
           <a:solidFill>
-            <a:srgbClr val="D9931D"/>
+            <a:srgbClr val="A6A6A6"/>
           </a:solidFill>
           <a:ln w="12700">
             <a:solidFill>
-              <a:srgbClr val="D9931D"/>
+              <a:srgbClr val="A6A6A6"/>
             </a:solidFill>
             <a:prstDash val="solid"/>
           </a:ln>
@@ -7122,11 +7158,11 @@
             </a:avLst>
           </a:prstGeom>
           <a:solidFill>
-            <a:srgbClr val="1F3A5F"/>
+            <a:srgbClr val="333333"/>
           </a:solidFill>
           <a:ln w="12700">
             <a:solidFill>
-              <a:srgbClr val="1F3A5F"/>
+              <a:srgbClr val="333333"/>
             </a:solidFill>
             <a:prstDash val="solid"/>
           </a:ln>
@@ -7147,11 +7183,11 @@
             <a:avLst/>
           </a:prstGeom>
           <a:solidFill>
-            <a:srgbClr val="D9931D"/>
+            <a:srgbClr val="A6A6A6"/>
           </a:solidFill>
           <a:ln w="12700">
             <a:solidFill>
-              <a:srgbClr val="D9931D"/>
+              <a:srgbClr val="A6A6A6"/>
             </a:solidFill>
             <a:prstDash val="solid"/>
           </a:ln>
@@ -7270,11 +7306,11 @@
             </a:avLst>
           </a:prstGeom>
           <a:solidFill>
-            <a:srgbClr val="1F3A5F"/>
+            <a:srgbClr val="333333"/>
           </a:solidFill>
           <a:ln w="12700">
             <a:solidFill>
-              <a:srgbClr val="1F3A5F"/>
+              <a:srgbClr val="333333"/>
             </a:solidFill>
             <a:prstDash val="solid"/>
           </a:ln>
@@ -7295,11 +7331,11 @@
             <a:avLst/>
           </a:prstGeom>
           <a:solidFill>
-            <a:srgbClr val="D9931D"/>
+            <a:srgbClr val="A6A6A6"/>
           </a:solidFill>
           <a:ln w="12700">
             <a:solidFill>
-              <a:srgbClr val="D9931D"/>
+              <a:srgbClr val="A6A6A6"/>
             </a:solidFill>
             <a:prstDash val="solid"/>
           </a:ln>
@@ -7431,7 +7467,7 @@
             <a:lvl1pPr>
               <a:defRPr sz="1000">
                 <a:solidFill>
-                  <a:srgbClr val="9BA7B4"/>
+                  <a:srgbClr val="BFBFBF"/>
                 </a:solidFill>
               </a:defRPr>
             </a:lvl1pPr>
@@ -7567,7 +7603,7 @@
                   <a:tcPr marL="54864" marR="54864" marT="54864" marB="54864" anchor="ctr">
                     <a:lnL w="6350" cap="flat" cmpd="sng" algn="ctr">
                       <a:solidFill>
-                        <a:srgbClr val="9BA7B4"/>
+                        <a:srgbClr val="BFBFBF"/>
                       </a:solidFill>
                       <a:prstDash val="solid"/>
                       <a:round/>
@@ -7576,7 +7612,7 @@
                     </a:lnL>
                     <a:lnR w="6350" cap="flat" cmpd="sng" algn="ctr">
                       <a:solidFill>
-                        <a:srgbClr val="9BA7B4"/>
+                        <a:srgbClr val="BFBFBF"/>
                       </a:solidFill>
                       <a:prstDash val="solid"/>
                       <a:round/>
@@ -7585,7 +7621,7 @@
                     </a:lnR>
                     <a:lnT w="6350" cap="flat" cmpd="sng" algn="ctr">
                       <a:solidFill>
-                        <a:srgbClr val="9BA7B4"/>
+                        <a:srgbClr val="BFBFBF"/>
                       </a:solidFill>
                       <a:prstDash val="solid"/>
                       <a:round/>
@@ -7594,7 +7630,7 @@
                     </a:lnT>
                     <a:lnB w="6350" cap="flat" cmpd="sng" algn="ctr">
                       <a:solidFill>
-                        <a:srgbClr val="9BA7B4"/>
+                        <a:srgbClr val="BFBFBF"/>
                       </a:solidFill>
                       <a:prstDash val="solid"/>
                       <a:round/>
@@ -7602,7 +7638,7 @@
                       <a:tailEnd type="none" w="med" len="med"/>
                     </a:lnB>
                     <a:solidFill>
-                      <a:srgbClr val="1F3A5F"/>
+                      <a:srgbClr val="333333"/>
                     </a:solidFill>
                   </a:tcPr>
                 </a:tc>
@@ -7635,7 +7671,7 @@
                   <a:tcPr marL="54864" marR="54864" marT="54864" marB="54864" anchor="ctr">
                     <a:lnL w="6350" cap="flat" cmpd="sng" algn="ctr">
                       <a:solidFill>
-                        <a:srgbClr val="9BA7B4"/>
+                        <a:srgbClr val="BFBFBF"/>
                       </a:solidFill>
                       <a:prstDash val="solid"/>
                       <a:round/>
@@ -7644,7 +7680,7 @@
                     </a:lnL>
                     <a:lnR w="6350" cap="flat" cmpd="sng" algn="ctr">
                       <a:solidFill>
-                        <a:srgbClr val="9BA7B4"/>
+                        <a:srgbClr val="BFBFBF"/>
                       </a:solidFill>
                       <a:prstDash val="solid"/>
                       <a:round/>
@@ -7653,7 +7689,7 @@
                     </a:lnR>
                     <a:lnT w="6350" cap="flat" cmpd="sng" algn="ctr">
                       <a:solidFill>
-                        <a:srgbClr val="9BA7B4"/>
+                        <a:srgbClr val="BFBFBF"/>
                       </a:solidFill>
                       <a:prstDash val="solid"/>
                       <a:round/>
@@ -7662,7 +7698,7 @@
                     </a:lnT>
                     <a:lnB w="6350" cap="flat" cmpd="sng" algn="ctr">
                       <a:solidFill>
-                        <a:srgbClr val="9BA7B4"/>
+                        <a:srgbClr val="BFBFBF"/>
                       </a:solidFill>
                       <a:prstDash val="solid"/>
                       <a:round/>
@@ -7670,7 +7706,7 @@
                       <a:tailEnd type="none" w="med" len="med"/>
                     </a:lnB>
                     <a:solidFill>
-                      <a:srgbClr val="1F3A5F"/>
+                      <a:srgbClr val="333333"/>
                     </a:solidFill>
                   </a:tcPr>
                 </a:tc>
@@ -7703,7 +7739,7 @@
                   <a:tcPr marL="54864" marR="54864" marT="54864" marB="54864" anchor="ctr">
                     <a:lnL w="6350" cap="flat" cmpd="sng" algn="ctr">
                       <a:solidFill>
-                        <a:srgbClr val="9BA7B4"/>
+                        <a:srgbClr val="BFBFBF"/>
                       </a:solidFill>
                       <a:prstDash val="solid"/>
                       <a:round/>
@@ -7712,7 +7748,7 @@
                     </a:lnL>
                     <a:lnR w="6350" cap="flat" cmpd="sng" algn="ctr">
                       <a:solidFill>
-                        <a:srgbClr val="9BA7B4"/>
+                        <a:srgbClr val="BFBFBF"/>
                       </a:solidFill>
                       <a:prstDash val="solid"/>
                       <a:round/>
@@ -7721,7 +7757,7 @@
                     </a:lnR>
                     <a:lnT w="6350" cap="flat" cmpd="sng" algn="ctr">
                       <a:solidFill>
-                        <a:srgbClr val="9BA7B4"/>
+                        <a:srgbClr val="BFBFBF"/>
                       </a:solidFill>
                       <a:prstDash val="solid"/>
                       <a:round/>
@@ -7730,7 +7766,7 @@
                     </a:lnT>
                     <a:lnB w="6350" cap="flat" cmpd="sng" algn="ctr">
                       <a:solidFill>
-                        <a:srgbClr val="9BA7B4"/>
+                        <a:srgbClr val="BFBFBF"/>
                       </a:solidFill>
                       <a:prstDash val="solid"/>
                       <a:round/>
@@ -7738,7 +7774,7 @@
                       <a:tailEnd type="none" w="med" len="med"/>
                     </a:lnB>
                     <a:solidFill>
-                      <a:srgbClr val="1F3A5F"/>
+                      <a:srgbClr val="333333"/>
                     </a:solidFill>
                   </a:tcPr>
                 </a:tc>
@@ -7771,7 +7807,7 @@
                   <a:tcPr marL="54864" marR="54864" marT="54864" marB="54864" anchor="ctr">
                     <a:lnL w="6350" cap="flat" cmpd="sng" algn="ctr">
                       <a:solidFill>
-                        <a:srgbClr val="9BA7B4"/>
+                        <a:srgbClr val="BFBFBF"/>
                       </a:solidFill>
                       <a:prstDash val="solid"/>
                       <a:round/>
@@ -7780,7 +7816,7 @@
                     </a:lnL>
                     <a:lnR w="6350" cap="flat" cmpd="sng" algn="ctr">
                       <a:solidFill>
-                        <a:srgbClr val="9BA7B4"/>
+                        <a:srgbClr val="BFBFBF"/>
                       </a:solidFill>
                       <a:prstDash val="solid"/>
                       <a:round/>
@@ -7789,7 +7825,7 @@
                     </a:lnR>
                     <a:lnT w="6350" cap="flat" cmpd="sng" algn="ctr">
                       <a:solidFill>
-                        <a:srgbClr val="9BA7B4"/>
+                        <a:srgbClr val="BFBFBF"/>
                       </a:solidFill>
                       <a:prstDash val="solid"/>
                       <a:round/>
@@ -7798,7 +7834,7 @@
                     </a:lnT>
                     <a:lnB w="6350" cap="flat" cmpd="sng" algn="ctr">
                       <a:solidFill>
-                        <a:srgbClr val="9BA7B4"/>
+                        <a:srgbClr val="BFBFBF"/>
                       </a:solidFill>
                       <a:prstDash val="solid"/>
                       <a:round/>
@@ -7806,7 +7842,7 @@
                       <a:tailEnd type="none" w="med" len="med"/>
                     </a:lnB>
                     <a:solidFill>
-                      <a:srgbClr val="1F3A5F"/>
+                      <a:srgbClr val="333333"/>
                     </a:solidFill>
                   </a:tcPr>
                 </a:tc>
@@ -7823,7 +7859,7 @@
                       <a:r>
                         <a:rPr lang="en-US" sz="1150" b="1" dirty="0">
                           <a:solidFill>
-                            <a:srgbClr val="1B1F2E"/>
+                            <a:srgbClr val="000000"/>
                           </a:solidFill>
                           <a:latin typeface="Calibri" pitchFamily="34" charset="0"/>
                           <a:ea typeface="Calibri" pitchFamily="34" charset="-122"/>
@@ -7841,7 +7877,7 @@
                   <a:tcPr marL="54864" marR="54864" marT="54864" marB="54864" anchor="ctr">
                     <a:lnL w="6350" cap="flat" cmpd="sng" algn="ctr">
                       <a:solidFill>
-                        <a:srgbClr val="9BA7B4"/>
+                        <a:srgbClr val="BFBFBF"/>
                       </a:solidFill>
                       <a:prstDash val="solid"/>
                       <a:round/>
@@ -7850,7 +7886,7 @@
                     </a:lnL>
                     <a:lnR w="6350" cap="flat" cmpd="sng" algn="ctr">
                       <a:solidFill>
-                        <a:srgbClr val="9BA7B4"/>
+                        <a:srgbClr val="BFBFBF"/>
                       </a:solidFill>
                       <a:prstDash val="solid"/>
                       <a:round/>
@@ -7859,7 +7895,7 @@
                     </a:lnR>
                     <a:lnT w="6350" cap="flat" cmpd="sng" algn="ctr">
                       <a:solidFill>
-                        <a:srgbClr val="9BA7B4"/>
+                        <a:srgbClr val="BFBFBF"/>
                       </a:solidFill>
                       <a:prstDash val="solid"/>
                       <a:round/>
@@ -7868,7 +7904,7 @@
                     </a:lnT>
                     <a:lnB w="6350" cap="flat" cmpd="sng" algn="ctr">
                       <a:solidFill>
-                        <a:srgbClr val="9BA7B4"/>
+                        <a:srgbClr val="BFBFBF"/>
                       </a:solidFill>
                       <a:prstDash val="solid"/>
                       <a:round/>
@@ -7876,7 +7912,7 @@
                       <a:tailEnd type="none" w="med" len="med"/>
                     </a:lnB>
                     <a:solidFill>
-                      <a:srgbClr val="EEF3F8"/>
+                      <a:srgbClr val="EDEDED"/>
                     </a:solidFill>
                   </a:tcPr>
                 </a:tc>
@@ -7891,7 +7927,7 @@
                       <a:r>
                         <a:rPr lang="en-US" sz="1150" dirty="0">
                           <a:solidFill>
-                            <a:srgbClr val="1B1F2E"/>
+                            <a:srgbClr val="000000"/>
                           </a:solidFill>
                           <a:latin typeface="Calibri" pitchFamily="34" charset="0"/>
                           <a:ea typeface="Calibri" pitchFamily="34" charset="-122"/>
@@ -7909,7 +7945,7 @@
                   <a:tcPr marL="54864" marR="54864" marT="54864" marB="54864" anchor="ctr">
                     <a:lnL w="6350" cap="flat" cmpd="sng" algn="ctr">
                       <a:solidFill>
-                        <a:srgbClr val="9BA7B4"/>
+                        <a:srgbClr val="BFBFBF"/>
                       </a:solidFill>
                       <a:prstDash val="solid"/>
                       <a:round/>
@@ -7918,7 +7954,7 @@
                     </a:lnL>
                     <a:lnR w="6350" cap="flat" cmpd="sng" algn="ctr">
                       <a:solidFill>
-                        <a:srgbClr val="9BA7B4"/>
+                        <a:srgbClr val="BFBFBF"/>
                       </a:solidFill>
                       <a:prstDash val="solid"/>
                       <a:round/>
@@ -7927,7 +7963,7 @@
                     </a:lnR>
                     <a:lnT w="6350" cap="flat" cmpd="sng" algn="ctr">
                       <a:solidFill>
-                        <a:srgbClr val="9BA7B4"/>
+                        <a:srgbClr val="BFBFBF"/>
                       </a:solidFill>
                       <a:prstDash val="solid"/>
                       <a:round/>
@@ -7936,7 +7972,7 @@
                     </a:lnT>
                     <a:lnB w="6350" cap="flat" cmpd="sng" algn="ctr">
                       <a:solidFill>
-                        <a:srgbClr val="9BA7B4"/>
+                        <a:srgbClr val="BFBFBF"/>
                       </a:solidFill>
                       <a:prstDash val="solid"/>
                       <a:round/>
@@ -7944,7 +7980,7 @@
                       <a:tailEnd type="none" w="med" len="med"/>
                     </a:lnB>
                     <a:solidFill>
-                      <a:srgbClr val="EEF3F8"/>
+                      <a:srgbClr val="EDEDED"/>
                     </a:solidFill>
                   </a:tcPr>
                 </a:tc>
@@ -7959,7 +7995,7 @@
                       <a:r>
                         <a:rPr lang="en-US" sz="1150" dirty="0">
                           <a:solidFill>
-                            <a:srgbClr val="1B1F2E"/>
+                            <a:srgbClr val="000000"/>
                           </a:solidFill>
                           <a:latin typeface="Calibri" pitchFamily="34" charset="0"/>
                           <a:ea typeface="Calibri" pitchFamily="34" charset="-122"/>
@@ -7977,7 +8013,7 @@
                   <a:tcPr marL="54864" marR="54864" marT="54864" marB="54864" anchor="ctr">
                     <a:lnL w="6350" cap="flat" cmpd="sng" algn="ctr">
                       <a:solidFill>
-                        <a:srgbClr val="9BA7B4"/>
+                        <a:srgbClr val="BFBFBF"/>
                       </a:solidFill>
                       <a:prstDash val="solid"/>
                       <a:round/>
@@ -7986,7 +8022,7 @@
                     </a:lnL>
                     <a:lnR w="6350" cap="flat" cmpd="sng" algn="ctr">
                       <a:solidFill>
-                        <a:srgbClr val="9BA7B4"/>
+                        <a:srgbClr val="BFBFBF"/>
                       </a:solidFill>
                       <a:prstDash val="solid"/>
                       <a:round/>
@@ -7995,7 +8031,7 @@
                     </a:lnR>
                     <a:lnT w="6350" cap="flat" cmpd="sng" algn="ctr">
                       <a:solidFill>
-                        <a:srgbClr val="9BA7B4"/>
+                        <a:srgbClr val="BFBFBF"/>
                       </a:solidFill>
                       <a:prstDash val="solid"/>
                       <a:round/>
@@ -8004,7 +8040,7 @@
                     </a:lnT>
                     <a:lnB w="6350" cap="flat" cmpd="sng" algn="ctr">
                       <a:solidFill>
-                        <a:srgbClr val="9BA7B4"/>
+                        <a:srgbClr val="BFBFBF"/>
                       </a:solidFill>
                       <a:prstDash val="solid"/>
                       <a:round/>
@@ -8012,7 +8048,7 @@
                       <a:tailEnd type="none" w="med" len="med"/>
                     </a:lnB>
                     <a:solidFill>
-                      <a:srgbClr val="EEF3F8"/>
+                      <a:srgbClr val="EDEDED"/>
                     </a:solidFill>
                   </a:tcPr>
                 </a:tc>
@@ -8027,7 +8063,7 @@
                       <a:r>
                         <a:rPr lang="en-US" sz="1150" dirty="0">
                           <a:solidFill>
-                            <a:srgbClr val="1B1F2E"/>
+                            <a:srgbClr val="000000"/>
                           </a:solidFill>
                           <a:latin typeface="Calibri" pitchFamily="34" charset="0"/>
                           <a:ea typeface="Calibri" pitchFamily="34" charset="-122"/>
@@ -8045,7 +8081,7 @@
                   <a:tcPr marL="54864" marR="54864" marT="54864" marB="54864" anchor="ctr">
                     <a:lnL w="6350" cap="flat" cmpd="sng" algn="ctr">
                       <a:solidFill>
-                        <a:srgbClr val="9BA7B4"/>
+                        <a:srgbClr val="BFBFBF"/>
                       </a:solidFill>
                       <a:prstDash val="solid"/>
                       <a:round/>
@@ -8054,7 +8090,7 @@
                     </a:lnL>
                     <a:lnR w="6350" cap="flat" cmpd="sng" algn="ctr">
                       <a:solidFill>
-                        <a:srgbClr val="9BA7B4"/>
+                        <a:srgbClr val="BFBFBF"/>
                       </a:solidFill>
                       <a:prstDash val="solid"/>
                       <a:round/>
@@ -8063,7 +8099,7 @@
                     </a:lnR>
                     <a:lnT w="6350" cap="flat" cmpd="sng" algn="ctr">
                       <a:solidFill>
-                        <a:srgbClr val="9BA7B4"/>
+                        <a:srgbClr val="BFBFBF"/>
                       </a:solidFill>
                       <a:prstDash val="solid"/>
                       <a:round/>
@@ -8072,7 +8108,7 @@
                     </a:lnT>
                     <a:lnB w="6350" cap="flat" cmpd="sng" algn="ctr">
                       <a:solidFill>
-                        <a:srgbClr val="9BA7B4"/>
+                        <a:srgbClr val="BFBFBF"/>
                       </a:solidFill>
                       <a:prstDash val="solid"/>
                       <a:round/>
@@ -8080,7 +8116,7 @@
                       <a:tailEnd type="none" w="med" len="med"/>
                     </a:lnB>
                     <a:solidFill>
-                      <a:srgbClr val="EEF3F8"/>
+                      <a:srgbClr val="EDEDED"/>
                     </a:solidFill>
                   </a:tcPr>
                 </a:tc>
@@ -8097,7 +8133,7 @@
                       <a:r>
                         <a:rPr lang="en-US" sz="1150" b="1" dirty="0">
                           <a:solidFill>
-                            <a:srgbClr val="1B1F2E"/>
+                            <a:srgbClr val="000000"/>
                           </a:solidFill>
                           <a:latin typeface="Calibri" pitchFamily="34" charset="0"/>
                           <a:ea typeface="Calibri" pitchFamily="34" charset="-122"/>
@@ -8115,7 +8151,7 @@
                   <a:tcPr marL="54864" marR="54864" marT="54864" marB="54864" anchor="ctr">
                     <a:lnL w="6350" cap="flat" cmpd="sng" algn="ctr">
                       <a:solidFill>
-                        <a:srgbClr val="9BA7B4"/>
+                        <a:srgbClr val="BFBFBF"/>
                       </a:solidFill>
                       <a:prstDash val="solid"/>
                       <a:round/>
@@ -8124,7 +8160,7 @@
                     </a:lnL>
                     <a:lnR w="6350" cap="flat" cmpd="sng" algn="ctr">
                       <a:solidFill>
-                        <a:srgbClr val="9BA7B4"/>
+                        <a:srgbClr val="BFBFBF"/>
                       </a:solidFill>
                       <a:prstDash val="solid"/>
                       <a:round/>
@@ -8133,7 +8169,7 @@
                     </a:lnR>
                     <a:lnT w="6350" cap="flat" cmpd="sng" algn="ctr">
                       <a:solidFill>
-                        <a:srgbClr val="9BA7B4"/>
+                        <a:srgbClr val="BFBFBF"/>
                       </a:solidFill>
                       <a:prstDash val="solid"/>
                       <a:round/>
@@ -8142,7 +8178,7 @@
                     </a:lnT>
                     <a:lnB w="6350" cap="flat" cmpd="sng" algn="ctr">
                       <a:solidFill>
-                        <a:srgbClr val="9BA7B4"/>
+                        <a:srgbClr val="BFBFBF"/>
                       </a:solidFill>
                       <a:prstDash val="solid"/>
                       <a:round/>
@@ -8165,7 +8201,7 @@
                       <a:r>
                         <a:rPr lang="en-US" sz="1150" dirty="0">
                           <a:solidFill>
-                            <a:srgbClr val="1B1F2E"/>
+                            <a:srgbClr val="000000"/>
                           </a:solidFill>
                           <a:latin typeface="Calibri" pitchFamily="34" charset="0"/>
                           <a:ea typeface="Calibri" pitchFamily="34" charset="-122"/>
@@ -8183,7 +8219,7 @@
                   <a:tcPr marL="54864" marR="54864" marT="54864" marB="54864" anchor="ctr">
                     <a:lnL w="6350" cap="flat" cmpd="sng" algn="ctr">
                       <a:solidFill>
-                        <a:srgbClr val="9BA7B4"/>
+                        <a:srgbClr val="BFBFBF"/>
                       </a:solidFill>
                       <a:prstDash val="solid"/>
                       <a:round/>
@@ -8192,7 +8228,7 @@
                     </a:lnL>
                     <a:lnR w="6350" cap="flat" cmpd="sng" algn="ctr">
                       <a:solidFill>
-                        <a:srgbClr val="9BA7B4"/>
+                        <a:srgbClr val="BFBFBF"/>
                       </a:solidFill>
                       <a:prstDash val="solid"/>
                       <a:round/>
@@ -8201,7 +8237,7 @@
                     </a:lnR>
                     <a:lnT w="6350" cap="flat" cmpd="sng" algn="ctr">
                       <a:solidFill>
-                        <a:srgbClr val="9BA7B4"/>
+                        <a:srgbClr val="BFBFBF"/>
                       </a:solidFill>
                       <a:prstDash val="solid"/>
                       <a:round/>
@@ -8210,7 +8246,7 @@
                     </a:lnT>
                     <a:lnB w="6350" cap="flat" cmpd="sng" algn="ctr">
                       <a:solidFill>
-                        <a:srgbClr val="9BA7B4"/>
+                        <a:srgbClr val="BFBFBF"/>
                       </a:solidFill>
                       <a:prstDash val="solid"/>
                       <a:round/>
@@ -8233,7 +8269,7 @@
                       <a:r>
                         <a:rPr lang="en-US" sz="1150" dirty="0">
                           <a:solidFill>
-                            <a:srgbClr val="1B1F2E"/>
+                            <a:srgbClr val="000000"/>
                           </a:solidFill>
                           <a:latin typeface="Calibri" pitchFamily="34" charset="0"/>
                           <a:ea typeface="Calibri" pitchFamily="34" charset="-122"/>
@@ -8251,7 +8287,7 @@
                   <a:tcPr marL="54864" marR="54864" marT="54864" marB="54864" anchor="ctr">
                     <a:lnL w="6350" cap="flat" cmpd="sng" algn="ctr">
                       <a:solidFill>
-                        <a:srgbClr val="9BA7B4"/>
+                        <a:srgbClr val="BFBFBF"/>
                       </a:solidFill>
                       <a:prstDash val="solid"/>
                       <a:round/>
@@ -8260,7 +8296,7 @@
                     </a:lnL>
                     <a:lnR w="6350" cap="flat" cmpd="sng" algn="ctr">
                       <a:solidFill>
-                        <a:srgbClr val="9BA7B4"/>
+                        <a:srgbClr val="BFBFBF"/>
                       </a:solidFill>
                       <a:prstDash val="solid"/>
                       <a:round/>
@@ -8269,7 +8305,7 @@
                     </a:lnR>
                     <a:lnT w="6350" cap="flat" cmpd="sng" algn="ctr">
                       <a:solidFill>
-                        <a:srgbClr val="9BA7B4"/>
+                        <a:srgbClr val="BFBFBF"/>
                       </a:solidFill>
                       <a:prstDash val="solid"/>
                       <a:round/>
@@ -8278,7 +8314,7 @@
                     </a:lnT>
                     <a:lnB w="6350" cap="flat" cmpd="sng" algn="ctr">
                       <a:solidFill>
-                        <a:srgbClr val="9BA7B4"/>
+                        <a:srgbClr val="BFBFBF"/>
                       </a:solidFill>
                       <a:prstDash val="solid"/>
                       <a:round/>
@@ -8301,7 +8337,7 @@
                       <a:r>
                         <a:rPr lang="en-US" sz="1150" dirty="0">
                           <a:solidFill>
-                            <a:srgbClr val="1B1F2E"/>
+                            <a:srgbClr val="000000"/>
                           </a:solidFill>
                           <a:latin typeface="Calibri" pitchFamily="34" charset="0"/>
                           <a:ea typeface="Calibri" pitchFamily="34" charset="-122"/>
@@ -8319,7 +8355,7 @@
                   <a:tcPr marL="54864" marR="54864" marT="54864" marB="54864" anchor="ctr">
                     <a:lnL w="6350" cap="flat" cmpd="sng" algn="ctr">
                       <a:solidFill>
-                        <a:srgbClr val="9BA7B4"/>
+                        <a:srgbClr val="BFBFBF"/>
                       </a:solidFill>
                       <a:prstDash val="solid"/>
                       <a:round/>
@@ -8328,7 +8364,7 @@
                     </a:lnL>
                     <a:lnR w="6350" cap="flat" cmpd="sng" algn="ctr">
                       <a:solidFill>
-                        <a:srgbClr val="9BA7B4"/>
+                        <a:srgbClr val="BFBFBF"/>
                       </a:solidFill>
                       <a:prstDash val="solid"/>
                       <a:round/>
@@ -8337,7 +8373,7 @@
                     </a:lnR>
                     <a:lnT w="6350" cap="flat" cmpd="sng" algn="ctr">
                       <a:solidFill>
-                        <a:srgbClr val="9BA7B4"/>
+                        <a:srgbClr val="BFBFBF"/>
                       </a:solidFill>
                       <a:prstDash val="solid"/>
                       <a:round/>
@@ -8346,7 +8382,7 @@
                     </a:lnT>
                     <a:lnB w="6350" cap="flat" cmpd="sng" algn="ctr">
                       <a:solidFill>
-                        <a:srgbClr val="9BA7B4"/>
+                        <a:srgbClr val="BFBFBF"/>
                       </a:solidFill>
                       <a:prstDash val="solid"/>
                       <a:round/>
@@ -8371,7 +8407,7 @@
                       <a:r>
                         <a:rPr lang="en-US" sz="1150" b="1" dirty="0">
                           <a:solidFill>
-                            <a:srgbClr val="1B1F2E"/>
+                            <a:srgbClr val="000000"/>
                           </a:solidFill>
                           <a:latin typeface="Calibri" pitchFamily="34" charset="0"/>
                           <a:ea typeface="Calibri" pitchFamily="34" charset="-122"/>
@@ -8389,7 +8425,7 @@
                   <a:tcPr marL="54864" marR="54864" marT="54864" marB="54864" anchor="ctr">
                     <a:lnL w="6350" cap="flat" cmpd="sng" algn="ctr">
                       <a:solidFill>
-                        <a:srgbClr val="9BA7B4"/>
+                        <a:srgbClr val="BFBFBF"/>
                       </a:solidFill>
                       <a:prstDash val="solid"/>
                       <a:round/>
@@ -8398,7 +8434,7 @@
                     </a:lnL>
                     <a:lnR w="6350" cap="flat" cmpd="sng" algn="ctr">
                       <a:solidFill>
-                        <a:srgbClr val="9BA7B4"/>
+                        <a:srgbClr val="BFBFBF"/>
                       </a:solidFill>
                       <a:prstDash val="solid"/>
                       <a:round/>
@@ -8407,7 +8443,7 @@
                     </a:lnR>
                     <a:lnT w="6350" cap="flat" cmpd="sng" algn="ctr">
                       <a:solidFill>
-                        <a:srgbClr val="9BA7B4"/>
+                        <a:srgbClr val="BFBFBF"/>
                       </a:solidFill>
                       <a:prstDash val="solid"/>
                       <a:round/>
@@ -8416,7 +8452,7 @@
                     </a:lnT>
                     <a:lnB w="6350" cap="flat" cmpd="sng" algn="ctr">
                       <a:solidFill>
-                        <a:srgbClr val="9BA7B4"/>
+                        <a:srgbClr val="BFBFBF"/>
                       </a:solidFill>
                       <a:prstDash val="solid"/>
                       <a:round/>
@@ -8424,7 +8460,7 @@
                       <a:tailEnd type="none" w="med" len="med"/>
                     </a:lnB>
                     <a:solidFill>
-                      <a:srgbClr val="EEF3F8"/>
+                      <a:srgbClr val="EDEDED"/>
                     </a:solidFill>
                   </a:tcPr>
                 </a:tc>
@@ -8439,7 +8475,7 @@
                       <a:r>
                         <a:rPr lang="en-US" sz="1150" dirty="0">
                           <a:solidFill>
-                            <a:srgbClr val="1B1F2E"/>
+                            <a:srgbClr val="000000"/>
                           </a:solidFill>
                           <a:latin typeface="Calibri" pitchFamily="34" charset="0"/>
                           <a:ea typeface="Calibri" pitchFamily="34" charset="-122"/>
@@ -8457,7 +8493,7 @@
                   <a:tcPr marL="54864" marR="54864" marT="54864" marB="54864" anchor="ctr">
                     <a:lnL w="6350" cap="flat" cmpd="sng" algn="ctr">
                       <a:solidFill>
-                        <a:srgbClr val="9BA7B4"/>
+                        <a:srgbClr val="BFBFBF"/>
                       </a:solidFill>
                       <a:prstDash val="solid"/>
                       <a:round/>
@@ -8466,7 +8502,7 @@
                     </a:lnL>
                     <a:lnR w="6350" cap="flat" cmpd="sng" algn="ctr">
                       <a:solidFill>
-                        <a:srgbClr val="9BA7B4"/>
+                        <a:srgbClr val="BFBFBF"/>
                       </a:solidFill>
                       <a:prstDash val="solid"/>
                       <a:round/>
@@ -8475,7 +8511,7 @@
                     </a:lnR>
                     <a:lnT w="6350" cap="flat" cmpd="sng" algn="ctr">
                       <a:solidFill>
-                        <a:srgbClr val="9BA7B4"/>
+                        <a:srgbClr val="BFBFBF"/>
                       </a:solidFill>
                       <a:prstDash val="solid"/>
                       <a:round/>
@@ -8484,7 +8520,7 @@
                     </a:lnT>
                     <a:lnB w="6350" cap="flat" cmpd="sng" algn="ctr">
                       <a:solidFill>
-                        <a:srgbClr val="9BA7B4"/>
+                        <a:srgbClr val="BFBFBF"/>
                       </a:solidFill>
                       <a:prstDash val="solid"/>
                       <a:round/>
@@ -8492,7 +8528,7 @@
                       <a:tailEnd type="none" w="med" len="med"/>
                     </a:lnB>
                     <a:solidFill>
-                      <a:srgbClr val="EEF3F8"/>
+                      <a:srgbClr val="EDEDED"/>
                     </a:solidFill>
                   </a:tcPr>
                 </a:tc>
@@ -8507,7 +8543,7 @@
                       <a:r>
                         <a:rPr lang="en-US" sz="1150" dirty="0">
                           <a:solidFill>
-                            <a:srgbClr val="1B1F2E"/>
+                            <a:srgbClr val="000000"/>
                           </a:solidFill>
                           <a:latin typeface="Calibri" pitchFamily="34" charset="0"/>
                           <a:ea typeface="Calibri" pitchFamily="34" charset="-122"/>
@@ -8525,7 +8561,7 @@
                   <a:tcPr marL="54864" marR="54864" marT="54864" marB="54864" anchor="ctr">
                     <a:lnL w="6350" cap="flat" cmpd="sng" algn="ctr">
                       <a:solidFill>
-                        <a:srgbClr val="9BA7B4"/>
+                        <a:srgbClr val="BFBFBF"/>
                       </a:solidFill>
                       <a:prstDash val="solid"/>
                       <a:round/>
@@ -8534,7 +8570,7 @@
                     </a:lnL>
                     <a:lnR w="6350" cap="flat" cmpd="sng" algn="ctr">
                       <a:solidFill>
-                        <a:srgbClr val="9BA7B4"/>
+                        <a:srgbClr val="BFBFBF"/>
                       </a:solidFill>
                       <a:prstDash val="solid"/>
                       <a:round/>
@@ -8543,7 +8579,7 @@
                     </a:lnR>
                     <a:lnT w="6350" cap="flat" cmpd="sng" algn="ctr">
                       <a:solidFill>
-                        <a:srgbClr val="9BA7B4"/>
+                        <a:srgbClr val="BFBFBF"/>
                       </a:solidFill>
                       <a:prstDash val="solid"/>
                       <a:round/>
@@ -8552,7 +8588,7 @@
                     </a:lnT>
                     <a:lnB w="6350" cap="flat" cmpd="sng" algn="ctr">
                       <a:solidFill>
-                        <a:srgbClr val="9BA7B4"/>
+                        <a:srgbClr val="BFBFBF"/>
                       </a:solidFill>
                       <a:prstDash val="solid"/>
                       <a:round/>
@@ -8560,7 +8596,7 @@
                       <a:tailEnd type="none" w="med" len="med"/>
                     </a:lnB>
                     <a:solidFill>
-                      <a:srgbClr val="EEF3F8"/>
+                      <a:srgbClr val="EDEDED"/>
                     </a:solidFill>
                   </a:tcPr>
                 </a:tc>
@@ -8575,7 +8611,7 @@
                       <a:r>
                         <a:rPr lang="en-US" sz="1150" dirty="0">
                           <a:solidFill>
-                            <a:srgbClr val="1B1F2E"/>
+                            <a:srgbClr val="000000"/>
                           </a:solidFill>
                           <a:latin typeface="Calibri" pitchFamily="34" charset="0"/>
                           <a:ea typeface="Calibri" pitchFamily="34" charset="-122"/>
@@ -8593,7 +8629,7 @@
                   <a:tcPr marL="54864" marR="54864" marT="54864" marB="54864" anchor="ctr">
                     <a:lnL w="6350" cap="flat" cmpd="sng" algn="ctr">
                       <a:solidFill>
-                        <a:srgbClr val="9BA7B4"/>
+                        <a:srgbClr val="BFBFBF"/>
                       </a:solidFill>
                       <a:prstDash val="solid"/>
                       <a:round/>
@@ -8602,7 +8638,7 @@
                     </a:lnL>
                     <a:lnR w="6350" cap="flat" cmpd="sng" algn="ctr">
                       <a:solidFill>
-                        <a:srgbClr val="9BA7B4"/>
+                        <a:srgbClr val="BFBFBF"/>
                       </a:solidFill>
                       <a:prstDash val="solid"/>
                       <a:round/>
@@ -8611,7 +8647,7 @@
                     </a:lnR>
                     <a:lnT w="6350" cap="flat" cmpd="sng" algn="ctr">
                       <a:solidFill>
-                        <a:srgbClr val="9BA7B4"/>
+                        <a:srgbClr val="BFBFBF"/>
                       </a:solidFill>
                       <a:prstDash val="solid"/>
                       <a:round/>
@@ -8620,7 +8656,7 @@
                     </a:lnT>
                     <a:lnB w="6350" cap="flat" cmpd="sng" algn="ctr">
                       <a:solidFill>
-                        <a:srgbClr val="9BA7B4"/>
+                        <a:srgbClr val="BFBFBF"/>
                       </a:solidFill>
                       <a:prstDash val="solid"/>
                       <a:round/>
@@ -8628,7 +8664,7 @@
                       <a:tailEnd type="none" w="med" len="med"/>
                     </a:lnB>
                     <a:solidFill>
-                      <a:srgbClr val="EEF3F8"/>
+                      <a:srgbClr val="EDEDED"/>
                     </a:solidFill>
                   </a:tcPr>
                 </a:tc>
@@ -8645,7 +8681,7 @@
                       <a:r>
                         <a:rPr lang="en-US" sz="1150" b="1" dirty="0">
                           <a:solidFill>
-                            <a:srgbClr val="1B1F2E"/>
+                            <a:srgbClr val="000000"/>
                           </a:solidFill>
                           <a:latin typeface="Calibri" pitchFamily="34" charset="0"/>
                           <a:ea typeface="Calibri" pitchFamily="34" charset="-122"/>
@@ -8663,7 +8699,7 @@
                   <a:tcPr marL="54864" marR="54864" marT="54864" marB="54864" anchor="ctr">
                     <a:lnL w="6350" cap="flat" cmpd="sng" algn="ctr">
                       <a:solidFill>
-                        <a:srgbClr val="9BA7B4"/>
+                        <a:srgbClr val="BFBFBF"/>
                       </a:solidFill>
                       <a:prstDash val="solid"/>
                       <a:round/>
@@ -8672,7 +8708,7 @@
                     </a:lnL>
                     <a:lnR w="6350" cap="flat" cmpd="sng" algn="ctr">
                       <a:solidFill>
-                        <a:srgbClr val="9BA7B4"/>
+                        <a:srgbClr val="BFBFBF"/>
                       </a:solidFill>
                       <a:prstDash val="solid"/>
                       <a:round/>
@@ -8681,7 +8717,7 @@
                     </a:lnR>
                     <a:lnT w="6350" cap="flat" cmpd="sng" algn="ctr">
                       <a:solidFill>
-                        <a:srgbClr val="9BA7B4"/>
+                        <a:srgbClr val="BFBFBF"/>
                       </a:solidFill>
                       <a:prstDash val="solid"/>
                       <a:round/>
@@ -8690,7 +8726,7 @@
                     </a:lnT>
                     <a:lnB w="6350" cap="flat" cmpd="sng" algn="ctr">
                       <a:solidFill>
-                        <a:srgbClr val="9BA7B4"/>
+                        <a:srgbClr val="BFBFBF"/>
                       </a:solidFill>
                       <a:prstDash val="solid"/>
                       <a:round/>
@@ -8713,7 +8749,7 @@
                       <a:r>
                         <a:rPr lang="en-US" sz="1150" dirty="0">
                           <a:solidFill>
-                            <a:srgbClr val="1B1F2E"/>
+                            <a:srgbClr val="000000"/>
                           </a:solidFill>
                           <a:latin typeface="Calibri" pitchFamily="34" charset="0"/>
                           <a:ea typeface="Calibri" pitchFamily="34" charset="-122"/>
@@ -8731,7 +8767,7 @@
                   <a:tcPr marL="54864" marR="54864" marT="54864" marB="54864" anchor="ctr">
                     <a:lnL w="6350" cap="flat" cmpd="sng" algn="ctr">
                       <a:solidFill>
-                        <a:srgbClr val="9BA7B4"/>
+                        <a:srgbClr val="BFBFBF"/>
                       </a:solidFill>
                       <a:prstDash val="solid"/>
                       <a:round/>
@@ -8740,7 +8776,7 @@
                     </a:lnL>
                     <a:lnR w="6350" cap="flat" cmpd="sng" algn="ctr">
                       <a:solidFill>
-                        <a:srgbClr val="9BA7B4"/>
+                        <a:srgbClr val="BFBFBF"/>
                       </a:solidFill>
                       <a:prstDash val="solid"/>
                       <a:round/>
@@ -8749,7 +8785,7 @@
                     </a:lnR>
                     <a:lnT w="6350" cap="flat" cmpd="sng" algn="ctr">
                       <a:solidFill>
-                        <a:srgbClr val="9BA7B4"/>
+                        <a:srgbClr val="BFBFBF"/>
                       </a:solidFill>
                       <a:prstDash val="solid"/>
                       <a:round/>
@@ -8758,7 +8794,7 @@
                     </a:lnT>
                     <a:lnB w="6350" cap="flat" cmpd="sng" algn="ctr">
                       <a:solidFill>
-                        <a:srgbClr val="9BA7B4"/>
+                        <a:srgbClr val="BFBFBF"/>
                       </a:solidFill>
                       <a:prstDash val="solid"/>
                       <a:round/>
@@ -8781,7 +8817,7 @@
                       <a:r>
                         <a:rPr lang="en-US" sz="1150" dirty="0">
                           <a:solidFill>
-                            <a:srgbClr val="1B1F2E"/>
+                            <a:srgbClr val="000000"/>
                           </a:solidFill>
                           <a:latin typeface="Calibri" pitchFamily="34" charset="0"/>
                           <a:ea typeface="Calibri" pitchFamily="34" charset="-122"/>
@@ -8799,7 +8835,7 @@
                   <a:tcPr marL="54864" marR="54864" marT="54864" marB="54864" anchor="ctr">
                     <a:lnL w="6350" cap="flat" cmpd="sng" algn="ctr">
                       <a:solidFill>
-                        <a:srgbClr val="9BA7B4"/>
+                        <a:srgbClr val="BFBFBF"/>
                       </a:solidFill>
                       <a:prstDash val="solid"/>
                       <a:round/>
@@ -8808,7 +8844,7 @@
                     </a:lnL>
                     <a:lnR w="6350" cap="flat" cmpd="sng" algn="ctr">
                       <a:solidFill>
-                        <a:srgbClr val="9BA7B4"/>
+                        <a:srgbClr val="BFBFBF"/>
                       </a:solidFill>
                       <a:prstDash val="solid"/>
                       <a:round/>
@@ -8817,7 +8853,7 @@
                     </a:lnR>
                     <a:lnT w="6350" cap="flat" cmpd="sng" algn="ctr">
                       <a:solidFill>
-                        <a:srgbClr val="9BA7B4"/>
+                        <a:srgbClr val="BFBFBF"/>
                       </a:solidFill>
                       <a:prstDash val="solid"/>
                       <a:round/>
@@ -8826,7 +8862,7 @@
                     </a:lnT>
                     <a:lnB w="6350" cap="flat" cmpd="sng" algn="ctr">
                       <a:solidFill>
-                        <a:srgbClr val="9BA7B4"/>
+                        <a:srgbClr val="BFBFBF"/>
                       </a:solidFill>
                       <a:prstDash val="solid"/>
                       <a:round/>
@@ -8849,7 +8885,7 @@
                       <a:r>
                         <a:rPr lang="en-US" sz="1150" dirty="0">
                           <a:solidFill>
-                            <a:srgbClr val="1B1F2E"/>
+                            <a:srgbClr val="000000"/>
                           </a:solidFill>
                           <a:latin typeface="Calibri" pitchFamily="34" charset="0"/>
                           <a:ea typeface="Calibri" pitchFamily="34" charset="-122"/>
@@ -8867,7 +8903,7 @@
                   <a:tcPr marL="54864" marR="54864" marT="54864" marB="54864" anchor="ctr">
                     <a:lnL w="6350" cap="flat" cmpd="sng" algn="ctr">
                       <a:solidFill>
-                        <a:srgbClr val="9BA7B4"/>
+                        <a:srgbClr val="BFBFBF"/>
                       </a:solidFill>
                       <a:prstDash val="solid"/>
                       <a:round/>
@@ -8876,7 +8912,7 @@
                     </a:lnL>
                     <a:lnR w="6350" cap="flat" cmpd="sng" algn="ctr">
                       <a:solidFill>
-                        <a:srgbClr val="9BA7B4"/>
+                        <a:srgbClr val="BFBFBF"/>
                       </a:solidFill>
                       <a:prstDash val="solid"/>
                       <a:round/>
@@ -8885,7 +8921,7 @@
                     </a:lnR>
                     <a:lnT w="6350" cap="flat" cmpd="sng" algn="ctr">
                       <a:solidFill>
-                        <a:srgbClr val="9BA7B4"/>
+                        <a:srgbClr val="BFBFBF"/>
                       </a:solidFill>
                       <a:prstDash val="solid"/>
                       <a:round/>
@@ -8894,7 +8930,7 @@
                     </a:lnT>
                     <a:lnB w="6350" cap="flat" cmpd="sng" algn="ctr">
                       <a:solidFill>
-                        <a:srgbClr val="9BA7B4"/>
+                        <a:srgbClr val="BFBFBF"/>
                       </a:solidFill>
                       <a:prstDash val="solid"/>
                       <a:round/>
@@ -8919,7 +8955,7 @@
                       <a:r>
                         <a:rPr lang="en-US" sz="1150" b="1" dirty="0">
                           <a:solidFill>
-                            <a:srgbClr val="1B1F2E"/>
+                            <a:srgbClr val="000000"/>
                           </a:solidFill>
                           <a:latin typeface="Calibri" pitchFamily="34" charset="0"/>
                           <a:ea typeface="Calibri" pitchFamily="34" charset="-122"/>
@@ -8937,7 +8973,7 @@
                   <a:tcPr marL="54864" marR="54864" marT="54864" marB="54864" anchor="ctr">
                     <a:lnL w="6350" cap="flat" cmpd="sng" algn="ctr">
                       <a:solidFill>
-                        <a:srgbClr val="9BA7B4"/>
+                        <a:srgbClr val="BFBFBF"/>
                       </a:solidFill>
                       <a:prstDash val="solid"/>
                       <a:round/>
@@ -8946,7 +8982,7 @@
                     </a:lnL>
                     <a:lnR w="6350" cap="flat" cmpd="sng" algn="ctr">
                       <a:solidFill>
-                        <a:srgbClr val="9BA7B4"/>
+                        <a:srgbClr val="BFBFBF"/>
                       </a:solidFill>
                       <a:prstDash val="solid"/>
                       <a:round/>
@@ -8955,7 +8991,7 @@
                     </a:lnR>
                     <a:lnT w="6350" cap="flat" cmpd="sng" algn="ctr">
                       <a:solidFill>
-                        <a:srgbClr val="9BA7B4"/>
+                        <a:srgbClr val="BFBFBF"/>
                       </a:solidFill>
                       <a:prstDash val="solid"/>
                       <a:round/>
@@ -8964,7 +9000,7 @@
                     </a:lnT>
                     <a:lnB w="6350" cap="flat" cmpd="sng" algn="ctr">
                       <a:solidFill>
-                        <a:srgbClr val="9BA7B4"/>
+                        <a:srgbClr val="BFBFBF"/>
                       </a:solidFill>
                       <a:prstDash val="solid"/>
                       <a:round/>
@@ -8972,7 +9008,7 @@
                       <a:tailEnd type="none" w="med" len="med"/>
                     </a:lnB>
                     <a:solidFill>
-                      <a:srgbClr val="EEF3F8"/>
+                      <a:srgbClr val="EDEDED"/>
                     </a:solidFill>
                   </a:tcPr>
                 </a:tc>
@@ -8987,7 +9023,7 @@
                       <a:r>
                         <a:rPr lang="en-US" sz="1150" dirty="0">
                           <a:solidFill>
-                            <a:srgbClr val="1B1F2E"/>
+                            <a:srgbClr val="000000"/>
                           </a:solidFill>
                           <a:latin typeface="Calibri" pitchFamily="34" charset="0"/>
                           <a:ea typeface="Calibri" pitchFamily="34" charset="-122"/>
@@ -9005,7 +9041,7 @@
                   <a:tcPr marL="54864" marR="54864" marT="54864" marB="54864" anchor="ctr">
                     <a:lnL w="6350" cap="flat" cmpd="sng" algn="ctr">
                       <a:solidFill>
-                        <a:srgbClr val="9BA7B4"/>
+                        <a:srgbClr val="BFBFBF"/>
                       </a:solidFill>
                       <a:prstDash val="solid"/>
                       <a:round/>
@@ -9014,7 +9050,7 @@
                     </a:lnL>
                     <a:lnR w="6350" cap="flat" cmpd="sng" algn="ctr">
                       <a:solidFill>
-                        <a:srgbClr val="9BA7B4"/>
+                        <a:srgbClr val="BFBFBF"/>
                       </a:solidFill>
                       <a:prstDash val="solid"/>
                       <a:round/>
@@ -9023,7 +9059,7 @@
                     </a:lnR>
                     <a:lnT w="6350" cap="flat" cmpd="sng" algn="ctr">
                       <a:solidFill>
-                        <a:srgbClr val="9BA7B4"/>
+                        <a:srgbClr val="BFBFBF"/>
                       </a:solidFill>
                       <a:prstDash val="solid"/>
                       <a:round/>
@@ -9032,7 +9068,7 @@
                     </a:lnT>
                     <a:lnB w="6350" cap="flat" cmpd="sng" algn="ctr">
                       <a:solidFill>
-                        <a:srgbClr val="9BA7B4"/>
+                        <a:srgbClr val="BFBFBF"/>
                       </a:solidFill>
                       <a:prstDash val="solid"/>
                       <a:round/>
@@ -9040,7 +9076,7 @@
                       <a:tailEnd type="none" w="med" len="med"/>
                     </a:lnB>
                     <a:solidFill>
-                      <a:srgbClr val="EEF3F8"/>
+                      <a:srgbClr val="EDEDED"/>
                     </a:solidFill>
                   </a:tcPr>
                 </a:tc>
@@ -9055,7 +9091,7 @@
                       <a:r>
                         <a:rPr lang="en-US" sz="1150" dirty="0">
                           <a:solidFill>
-                            <a:srgbClr val="1B1F2E"/>
+                            <a:srgbClr val="000000"/>
                           </a:solidFill>
                           <a:latin typeface="Calibri" pitchFamily="34" charset="0"/>
                           <a:ea typeface="Calibri" pitchFamily="34" charset="-122"/>
@@ -9073,7 +9109,7 @@
                   <a:tcPr marL="54864" marR="54864" marT="54864" marB="54864" anchor="ctr">
                     <a:lnL w="6350" cap="flat" cmpd="sng" algn="ctr">
                       <a:solidFill>
-                        <a:srgbClr val="9BA7B4"/>
+                        <a:srgbClr val="BFBFBF"/>
                       </a:solidFill>
                       <a:prstDash val="solid"/>
                       <a:round/>
@@ -9082,7 +9118,7 @@
                     </a:lnL>
                     <a:lnR w="6350" cap="flat" cmpd="sng" algn="ctr">
                       <a:solidFill>
-                        <a:srgbClr val="9BA7B4"/>
+                        <a:srgbClr val="BFBFBF"/>
                       </a:solidFill>
                       <a:prstDash val="solid"/>
                       <a:round/>
@@ -9091,7 +9127,7 @@
                     </a:lnR>
                     <a:lnT w="6350" cap="flat" cmpd="sng" algn="ctr">
                       <a:solidFill>
-                        <a:srgbClr val="9BA7B4"/>
+                        <a:srgbClr val="BFBFBF"/>
                       </a:solidFill>
                       <a:prstDash val="solid"/>
                       <a:round/>
@@ -9100,7 +9136,7 @@
                     </a:lnT>
                     <a:lnB w="6350" cap="flat" cmpd="sng" algn="ctr">
                       <a:solidFill>
-                        <a:srgbClr val="9BA7B4"/>
+                        <a:srgbClr val="BFBFBF"/>
                       </a:solidFill>
                       <a:prstDash val="solid"/>
                       <a:round/>
@@ -9108,7 +9144,7 @@
                       <a:tailEnd type="none" w="med" len="med"/>
                     </a:lnB>
                     <a:solidFill>
-                      <a:srgbClr val="EEF3F8"/>
+                      <a:srgbClr val="EDEDED"/>
                     </a:solidFill>
                   </a:tcPr>
                 </a:tc>
@@ -9123,7 +9159,7 @@
                       <a:r>
                         <a:rPr lang="en-US" sz="1150" dirty="0">
                           <a:solidFill>
-                            <a:srgbClr val="1B1F2E"/>
+                            <a:srgbClr val="000000"/>
                           </a:solidFill>
                           <a:latin typeface="Calibri" pitchFamily="34" charset="0"/>
                           <a:ea typeface="Calibri" pitchFamily="34" charset="-122"/>
@@ -9141,7 +9177,7 @@
                   <a:tcPr marL="54864" marR="54864" marT="54864" marB="54864" anchor="ctr">
                     <a:lnL w="6350" cap="flat" cmpd="sng" algn="ctr">
                       <a:solidFill>
-                        <a:srgbClr val="9BA7B4"/>
+                        <a:srgbClr val="BFBFBF"/>
                       </a:solidFill>
                       <a:prstDash val="solid"/>
                       <a:round/>
@@ -9150,7 +9186,7 @@
                     </a:lnL>
                     <a:lnR w="6350" cap="flat" cmpd="sng" algn="ctr">
                       <a:solidFill>
-                        <a:srgbClr val="9BA7B4"/>
+                        <a:srgbClr val="BFBFBF"/>
                       </a:solidFill>
                       <a:prstDash val="solid"/>
                       <a:round/>
@@ -9159,7 +9195,7 @@
                     </a:lnR>
                     <a:lnT w="6350" cap="flat" cmpd="sng" algn="ctr">
                       <a:solidFill>
-                        <a:srgbClr val="9BA7B4"/>
+                        <a:srgbClr val="BFBFBF"/>
                       </a:solidFill>
                       <a:prstDash val="solid"/>
                       <a:round/>
@@ -9168,7 +9204,7 @@
                     </a:lnT>
                     <a:lnB w="6350" cap="flat" cmpd="sng" algn="ctr">
                       <a:solidFill>
-                        <a:srgbClr val="9BA7B4"/>
+                        <a:srgbClr val="BFBFBF"/>
                       </a:solidFill>
                       <a:prstDash val="solid"/>
                       <a:round/>
@@ -9176,7 +9212,7 @@
                       <a:tailEnd type="none" w="med" len="med"/>
                     </a:lnB>
                     <a:solidFill>
-                      <a:srgbClr val="EEF3F8"/>
+                      <a:srgbClr val="EDEDED"/>
                     </a:solidFill>
                   </a:tcPr>
                 </a:tc>
@@ -9193,7 +9229,7 @@
                       <a:r>
                         <a:rPr lang="en-US" sz="1150" b="1" dirty="0">
                           <a:solidFill>
-                            <a:srgbClr val="1B1F2E"/>
+                            <a:srgbClr val="000000"/>
                           </a:solidFill>
                           <a:latin typeface="Calibri" pitchFamily="34" charset="0"/>
                           <a:ea typeface="Calibri" pitchFamily="34" charset="-122"/>
@@ -9211,7 +9247,7 @@
                   <a:tcPr marL="54864" marR="54864" marT="54864" marB="54864" anchor="ctr">
                     <a:lnL w="6350" cap="flat" cmpd="sng" algn="ctr">
                       <a:solidFill>
-                        <a:srgbClr val="9BA7B4"/>
+                        <a:srgbClr val="BFBFBF"/>
                       </a:solidFill>
                       <a:prstDash val="solid"/>
                       <a:round/>
@@ -9220,7 +9256,7 @@
                     </a:lnL>
                     <a:lnR w="6350" cap="flat" cmpd="sng" algn="ctr">
                       <a:solidFill>
-                        <a:srgbClr val="9BA7B4"/>
+                        <a:srgbClr val="BFBFBF"/>
                       </a:solidFill>
                       <a:prstDash val="solid"/>
                       <a:round/>
@@ -9229,7 +9265,7 @@
                     </a:lnR>
                     <a:lnT w="6350" cap="flat" cmpd="sng" algn="ctr">
                       <a:solidFill>
-                        <a:srgbClr val="9BA7B4"/>
+                        <a:srgbClr val="BFBFBF"/>
                       </a:solidFill>
                       <a:prstDash val="solid"/>
                       <a:round/>
@@ -9238,7 +9274,7 @@
                     </a:lnT>
                     <a:lnB w="6350" cap="flat" cmpd="sng" algn="ctr">
                       <a:solidFill>
-                        <a:srgbClr val="9BA7B4"/>
+                        <a:srgbClr val="BFBFBF"/>
                       </a:solidFill>
                       <a:prstDash val="solid"/>
                       <a:round/>
@@ -9261,7 +9297,7 @@
                       <a:r>
                         <a:rPr lang="en-US" sz="1150" dirty="0">
                           <a:solidFill>
-                            <a:srgbClr val="1B1F2E"/>
+                            <a:srgbClr val="000000"/>
                           </a:solidFill>
                           <a:latin typeface="Calibri" pitchFamily="34" charset="0"/>
                           <a:ea typeface="Calibri" pitchFamily="34" charset="-122"/>
@@ -9279,7 +9315,7 @@
                   <a:tcPr marL="54864" marR="54864" marT="54864" marB="54864" anchor="ctr">
                     <a:lnL w="6350" cap="flat" cmpd="sng" algn="ctr">
                       <a:solidFill>
-                        <a:srgbClr val="9BA7B4"/>
+                        <a:srgbClr val="BFBFBF"/>
                       </a:solidFill>
                       <a:prstDash val="solid"/>
                       <a:round/>
@@ -9288,7 +9324,7 @@
                     </a:lnL>
                     <a:lnR w="6350" cap="flat" cmpd="sng" algn="ctr">
                       <a:solidFill>
-                        <a:srgbClr val="9BA7B4"/>
+                        <a:srgbClr val="BFBFBF"/>
                       </a:solidFill>
                       <a:prstDash val="solid"/>
                       <a:round/>
@@ -9297,7 +9333,7 @@
                     </a:lnR>
                     <a:lnT w="6350" cap="flat" cmpd="sng" algn="ctr">
                       <a:solidFill>
-                        <a:srgbClr val="9BA7B4"/>
+                        <a:srgbClr val="BFBFBF"/>
                       </a:solidFill>
                       <a:prstDash val="solid"/>
                       <a:round/>
@@ -9306,7 +9342,7 @@
                     </a:lnT>
                     <a:lnB w="6350" cap="flat" cmpd="sng" algn="ctr">
                       <a:solidFill>
-                        <a:srgbClr val="9BA7B4"/>
+                        <a:srgbClr val="BFBFBF"/>
                       </a:solidFill>
                       <a:prstDash val="solid"/>
                       <a:round/>
@@ -9329,7 +9365,7 @@
                       <a:r>
                         <a:rPr lang="en-US" sz="1150" dirty="0">
                           <a:solidFill>
-                            <a:srgbClr val="1B1F2E"/>
+                            <a:srgbClr val="000000"/>
                           </a:solidFill>
                           <a:latin typeface="Calibri" pitchFamily="34" charset="0"/>
                           <a:ea typeface="Calibri" pitchFamily="34" charset="-122"/>
@@ -9347,7 +9383,7 @@
                   <a:tcPr marL="54864" marR="54864" marT="54864" marB="54864" anchor="ctr">
                     <a:lnL w="6350" cap="flat" cmpd="sng" algn="ctr">
                       <a:solidFill>
-                        <a:srgbClr val="9BA7B4"/>
+                        <a:srgbClr val="BFBFBF"/>
                       </a:solidFill>
                       <a:prstDash val="solid"/>
                       <a:round/>
@@ -9356,7 +9392,7 @@
                     </a:lnL>
                     <a:lnR w="6350" cap="flat" cmpd="sng" algn="ctr">
                       <a:solidFill>
-                        <a:srgbClr val="9BA7B4"/>
+                        <a:srgbClr val="BFBFBF"/>
                       </a:solidFill>
                       <a:prstDash val="solid"/>
                       <a:round/>
@@ -9365,7 +9401,7 @@
                     </a:lnR>
                     <a:lnT w="6350" cap="flat" cmpd="sng" algn="ctr">
                       <a:solidFill>
-                        <a:srgbClr val="9BA7B4"/>
+                        <a:srgbClr val="BFBFBF"/>
                       </a:solidFill>
                       <a:prstDash val="solid"/>
                       <a:round/>
@@ -9374,7 +9410,7 @@
                     </a:lnT>
                     <a:lnB w="6350" cap="flat" cmpd="sng" algn="ctr">
                       <a:solidFill>
-                        <a:srgbClr val="9BA7B4"/>
+                        <a:srgbClr val="BFBFBF"/>
                       </a:solidFill>
                       <a:prstDash val="solid"/>
                       <a:round/>
@@ -9397,7 +9433,7 @@
                       <a:r>
                         <a:rPr lang="en-US" sz="1150" dirty="0">
                           <a:solidFill>
-                            <a:srgbClr val="1B1F2E"/>
+                            <a:srgbClr val="000000"/>
                           </a:solidFill>
                           <a:latin typeface="Calibri" pitchFamily="34" charset="0"/>
                           <a:ea typeface="Calibri" pitchFamily="34" charset="-122"/>
@@ -9415,7 +9451,7 @@
                   <a:tcPr marL="54864" marR="54864" marT="54864" marB="54864" anchor="ctr">
                     <a:lnL w="6350" cap="flat" cmpd="sng" algn="ctr">
                       <a:solidFill>
-                        <a:srgbClr val="9BA7B4"/>
+                        <a:srgbClr val="BFBFBF"/>
                       </a:solidFill>
                       <a:prstDash val="solid"/>
                       <a:round/>
@@ -9424,7 +9460,7 @@
                     </a:lnL>
                     <a:lnR w="6350" cap="flat" cmpd="sng" algn="ctr">
                       <a:solidFill>
-                        <a:srgbClr val="9BA7B4"/>
+                        <a:srgbClr val="BFBFBF"/>
                       </a:solidFill>
                       <a:prstDash val="solid"/>
                       <a:round/>
@@ -9433,7 +9469,7 @@
                     </a:lnR>
                     <a:lnT w="6350" cap="flat" cmpd="sng" algn="ctr">
                       <a:solidFill>
-                        <a:srgbClr val="9BA7B4"/>
+                        <a:srgbClr val="BFBFBF"/>
                       </a:solidFill>
                       <a:prstDash val="solid"/>
                       <a:round/>
@@ -9442,7 +9478,7 @@
                     </a:lnT>
                     <a:lnB w="6350" cap="flat" cmpd="sng" algn="ctr">
                       <a:solidFill>
-                        <a:srgbClr val="9BA7B4"/>
+                        <a:srgbClr val="BFBFBF"/>
                       </a:solidFill>
                       <a:prstDash val="solid"/>
                       <a:round/>
@@ -9467,7 +9503,7 @@
                       <a:r>
                         <a:rPr lang="en-US" sz="1150" b="1" dirty="0">
                           <a:solidFill>
-                            <a:srgbClr val="1B1F2E"/>
+                            <a:srgbClr val="000000"/>
                           </a:solidFill>
                           <a:latin typeface="Calibri" pitchFamily="34" charset="0"/>
                           <a:ea typeface="Calibri" pitchFamily="34" charset="-122"/>
@@ -9485,7 +9521,7 @@
                   <a:tcPr marL="54864" marR="54864" marT="54864" marB="54864" anchor="ctr">
                     <a:lnL w="6350" cap="flat" cmpd="sng" algn="ctr">
                       <a:solidFill>
-                        <a:srgbClr val="9BA7B4"/>
+                        <a:srgbClr val="BFBFBF"/>
                       </a:solidFill>
                       <a:prstDash val="solid"/>
                       <a:round/>
@@ -9494,7 +9530,7 @@
                     </a:lnL>
                     <a:lnR w="6350" cap="flat" cmpd="sng" algn="ctr">
                       <a:solidFill>
-                        <a:srgbClr val="9BA7B4"/>
+                        <a:srgbClr val="BFBFBF"/>
                       </a:solidFill>
                       <a:prstDash val="solid"/>
                       <a:round/>
@@ -9503,7 +9539,7 @@
                     </a:lnR>
                     <a:lnT w="6350" cap="flat" cmpd="sng" algn="ctr">
                       <a:solidFill>
-                        <a:srgbClr val="9BA7B4"/>
+                        <a:srgbClr val="BFBFBF"/>
                       </a:solidFill>
                       <a:prstDash val="solid"/>
                       <a:round/>
@@ -9512,7 +9548,7 @@
                     </a:lnT>
                     <a:lnB w="6350" cap="flat" cmpd="sng" algn="ctr">
                       <a:solidFill>
-                        <a:srgbClr val="9BA7B4"/>
+                        <a:srgbClr val="BFBFBF"/>
                       </a:solidFill>
                       <a:prstDash val="solid"/>
                       <a:round/>
@@ -9520,7 +9556,7 @@
                       <a:tailEnd type="none" w="med" len="med"/>
                     </a:lnB>
                     <a:solidFill>
-                      <a:srgbClr val="EEF3F8"/>
+                      <a:srgbClr val="EDEDED"/>
                     </a:solidFill>
                   </a:tcPr>
                 </a:tc>
@@ -9535,7 +9571,7 @@
                       <a:r>
                         <a:rPr lang="en-US" sz="1150" dirty="0">
                           <a:solidFill>
-                            <a:srgbClr val="1B1F2E"/>
+                            <a:srgbClr val="000000"/>
                           </a:solidFill>
                           <a:latin typeface="Calibri" pitchFamily="34" charset="0"/>
                           <a:ea typeface="Calibri" pitchFamily="34" charset="-122"/>
@@ -9553,7 +9589,7 @@
                   <a:tcPr marL="54864" marR="54864" marT="54864" marB="54864" anchor="ctr">
                     <a:lnL w="6350" cap="flat" cmpd="sng" algn="ctr">
                       <a:solidFill>
-                        <a:srgbClr val="9BA7B4"/>
+                        <a:srgbClr val="BFBFBF"/>
                       </a:solidFill>
                       <a:prstDash val="solid"/>
                       <a:round/>
@@ -9562,7 +9598,7 @@
                     </a:lnL>
                     <a:lnR w="6350" cap="flat" cmpd="sng" algn="ctr">
                       <a:solidFill>
-                        <a:srgbClr val="9BA7B4"/>
+                        <a:srgbClr val="BFBFBF"/>
                       </a:solidFill>
                       <a:prstDash val="solid"/>
                       <a:round/>
@@ -9571,7 +9607,7 @@
                     </a:lnR>
                     <a:lnT w="6350" cap="flat" cmpd="sng" algn="ctr">
                       <a:solidFill>
-                        <a:srgbClr val="9BA7B4"/>
+                        <a:srgbClr val="BFBFBF"/>
                       </a:solidFill>
                       <a:prstDash val="solid"/>
                       <a:round/>
@@ -9580,7 +9616,7 @@
                     </a:lnT>
                     <a:lnB w="6350" cap="flat" cmpd="sng" algn="ctr">
                       <a:solidFill>
-                        <a:srgbClr val="9BA7B4"/>
+                        <a:srgbClr val="BFBFBF"/>
                       </a:solidFill>
                       <a:prstDash val="solid"/>
                       <a:round/>
@@ -9588,7 +9624,7 @@
                       <a:tailEnd type="none" w="med" len="med"/>
                     </a:lnB>
                     <a:solidFill>
-                      <a:srgbClr val="EEF3F8"/>
+                      <a:srgbClr val="EDEDED"/>
                     </a:solidFill>
                   </a:tcPr>
                 </a:tc>
@@ -9603,7 +9639,7 @@
                       <a:r>
                         <a:rPr lang="en-US" sz="1150" dirty="0">
                           <a:solidFill>
-                            <a:srgbClr val="1B1F2E"/>
+                            <a:srgbClr val="000000"/>
                           </a:solidFill>
                           <a:latin typeface="Calibri" pitchFamily="34" charset="0"/>
                           <a:ea typeface="Calibri" pitchFamily="34" charset="-122"/>
@@ -9621,7 +9657,7 @@
                   <a:tcPr marL="54864" marR="54864" marT="54864" marB="54864" anchor="ctr">
                     <a:lnL w="6350" cap="flat" cmpd="sng" algn="ctr">
                       <a:solidFill>
-                        <a:srgbClr val="9BA7B4"/>
+                        <a:srgbClr val="BFBFBF"/>
                       </a:solidFill>
                       <a:prstDash val="solid"/>
                       <a:round/>
@@ -9630,7 +9666,7 @@
                     </a:lnL>
                     <a:lnR w="6350" cap="flat" cmpd="sng" algn="ctr">
                       <a:solidFill>
-                        <a:srgbClr val="9BA7B4"/>
+                        <a:srgbClr val="BFBFBF"/>
                       </a:solidFill>
                       <a:prstDash val="solid"/>
                       <a:round/>
@@ -9639,7 +9675,7 @@
                     </a:lnR>
                     <a:lnT w="6350" cap="flat" cmpd="sng" algn="ctr">
                       <a:solidFill>
-                        <a:srgbClr val="9BA7B4"/>
+                        <a:srgbClr val="BFBFBF"/>
                       </a:solidFill>
                       <a:prstDash val="solid"/>
                       <a:round/>
@@ -9648,7 +9684,7 @@
                     </a:lnT>
                     <a:lnB w="6350" cap="flat" cmpd="sng" algn="ctr">
                       <a:solidFill>
-                        <a:srgbClr val="9BA7B4"/>
+                        <a:srgbClr val="BFBFBF"/>
                       </a:solidFill>
                       <a:prstDash val="solid"/>
                       <a:round/>
@@ -9656,7 +9692,7 @@
                       <a:tailEnd type="none" w="med" len="med"/>
                     </a:lnB>
                     <a:solidFill>
-                      <a:srgbClr val="EEF3F8"/>
+                      <a:srgbClr val="EDEDED"/>
                     </a:solidFill>
                   </a:tcPr>
                 </a:tc>
@@ -9671,7 +9707,7 @@
                       <a:r>
                         <a:rPr lang="en-US" sz="1150" dirty="0">
                           <a:solidFill>
-                            <a:srgbClr val="1B1F2E"/>
+                            <a:srgbClr val="000000"/>
                           </a:solidFill>
                           <a:latin typeface="Calibri" pitchFamily="34" charset="0"/>
                           <a:ea typeface="Calibri" pitchFamily="34" charset="-122"/>
@@ -9689,7 +9725,7 @@
                   <a:tcPr marL="54864" marR="54864" marT="54864" marB="54864" anchor="ctr">
                     <a:lnL w="6350" cap="flat" cmpd="sng" algn="ctr">
                       <a:solidFill>
-                        <a:srgbClr val="9BA7B4"/>
+                        <a:srgbClr val="BFBFBF"/>
                       </a:solidFill>
                       <a:prstDash val="solid"/>
                       <a:round/>
@@ -9698,7 +9734,7 @@
                     </a:lnL>
                     <a:lnR w="6350" cap="flat" cmpd="sng" algn="ctr">
                       <a:solidFill>
-                        <a:srgbClr val="9BA7B4"/>
+                        <a:srgbClr val="BFBFBF"/>
                       </a:solidFill>
                       <a:prstDash val="solid"/>
                       <a:round/>
@@ -9707,7 +9743,7 @@
                     </a:lnR>
                     <a:lnT w="6350" cap="flat" cmpd="sng" algn="ctr">
                       <a:solidFill>
-                        <a:srgbClr val="9BA7B4"/>
+                        <a:srgbClr val="BFBFBF"/>
                       </a:solidFill>
                       <a:prstDash val="solid"/>
                       <a:round/>
@@ -9716,7 +9752,7 @@
                     </a:lnT>
                     <a:lnB w="6350" cap="flat" cmpd="sng" algn="ctr">
                       <a:solidFill>
-                        <a:srgbClr val="9BA7B4"/>
+                        <a:srgbClr val="BFBFBF"/>
                       </a:solidFill>
                       <a:prstDash val="solid"/>
                       <a:round/>
@@ -9724,7 +9760,7 @@
                       <a:tailEnd type="none" w="med" len="med"/>
                     </a:lnB>
                     <a:solidFill>
-                      <a:srgbClr val="EEF3F8"/>
+                      <a:srgbClr val="EDEDED"/>
                     </a:solidFill>
                   </a:tcPr>
                 </a:tc>
@@ -9763,7 +9799,7 @@
             <a:lvl1pPr>
               <a:defRPr sz="1000">
                 <a:solidFill>
-                  <a:srgbClr val="4A6670"/>
+                  <a:srgbClr val="595959"/>
                 </a:solidFill>
               </a:defRPr>
             </a:lvl1pPr>
@@ -9858,11 +9894,11 @@
             </a:avLst>
           </a:prstGeom>
           <a:solidFill>
-            <a:srgbClr val="1F3A5F"/>
+            <a:srgbClr val="333333"/>
           </a:solidFill>
           <a:ln w="12700">
             <a:solidFill>
-              <a:srgbClr val="1F3A5F"/>
+              <a:srgbClr val="333333"/>
             </a:solidFill>
             <a:prstDash val="solid"/>
           </a:ln>
@@ -9883,11 +9919,11 @@
             <a:avLst/>
           </a:prstGeom>
           <a:solidFill>
-            <a:srgbClr val="D9931D"/>
+            <a:srgbClr val="A6A6A6"/>
           </a:solidFill>
           <a:ln w="12700">
             <a:solidFill>
-              <a:srgbClr val="D9931D"/>
+              <a:srgbClr val="A6A6A6"/>
             </a:solidFill>
             <a:prstDash val="solid"/>
           </a:ln>
@@ -10053,11 +10089,11 @@
             <a:avLst/>
           </a:prstGeom>
           <a:solidFill>
-            <a:srgbClr val="D9931D"/>
+            <a:srgbClr val="A6A6A6"/>
           </a:solidFill>
           <a:ln w="12700">
             <a:solidFill>
-              <a:srgbClr val="D9931D"/>
+              <a:srgbClr val="A6A6A6"/>
             </a:solidFill>
             <a:prstDash val="solid"/>
           </a:ln>
@@ -10090,7 +10126,7 @@
             <a:r>
               <a:rPr lang="en-US" sz="1400" b="1" dirty="0">
                 <a:solidFill>
-                  <a:schemeClr val="bg1"/>
+                  <a:srgbClr val="000000"/>
                 </a:solidFill>
               </a:rPr>
               <a:t>1</a:t>
@@ -10150,11 +10186,11 @@
             <a:avLst/>
           </a:prstGeom>
           <a:solidFill>
-            <a:srgbClr val="D9931D"/>
+            <a:srgbClr val="A6A6A6"/>
           </a:solidFill>
           <a:ln w="12700">
             <a:solidFill>
-              <a:srgbClr val="D9931D"/>
+              <a:srgbClr val="A6A6A6"/>
             </a:solidFill>
             <a:prstDash val="solid"/>
           </a:ln>
@@ -10187,7 +10223,7 @@
             <a:r>
               <a:rPr lang="en-US" sz="1400" b="1" dirty="0">
                 <a:solidFill>
-                  <a:schemeClr val="bg1"/>
+                  <a:srgbClr val="000000"/>
                 </a:solidFill>
               </a:rPr>
               <a:t>2</a:t>
@@ -10247,11 +10283,11 @@
             <a:avLst/>
           </a:prstGeom>
           <a:solidFill>
-            <a:srgbClr val="D9931D"/>
+            <a:srgbClr val="A6A6A6"/>
           </a:solidFill>
           <a:ln w="12700">
             <a:solidFill>
-              <a:srgbClr val="D9931D"/>
+              <a:srgbClr val="A6A6A6"/>
             </a:solidFill>
             <a:prstDash val="solid"/>
           </a:ln>
@@ -10284,7 +10320,7 @@
             <a:r>
               <a:rPr lang="en-US" sz="1400" b="1" dirty="0">
                 <a:solidFill>
-                  <a:schemeClr val="bg1"/>
+                  <a:srgbClr val="000000"/>
                 </a:solidFill>
               </a:rPr>
               <a:t>3</a:t>
@@ -10395,7 +10431,7 @@
             <a:lvl1pPr>
               <a:defRPr sz="1000">
                 <a:solidFill>
-                  <a:srgbClr val="9BA7B4"/>
+                  <a:srgbClr val="BFBFBF"/>
                 </a:solidFill>
               </a:defRPr>
             </a:lvl1pPr>
@@ -10490,11 +10526,11 @@
             </a:avLst>
           </a:prstGeom>
           <a:solidFill>
-            <a:srgbClr val="1F3A5F"/>
+            <a:srgbClr val="333333"/>
           </a:solidFill>
           <a:ln w="12700">
             <a:solidFill>
-              <a:srgbClr val="1F3A5F"/>
+              <a:srgbClr val="333333"/>
             </a:solidFill>
             <a:prstDash val="solid"/>
           </a:ln>
@@ -10515,11 +10551,11 @@
             <a:avLst/>
           </a:prstGeom>
           <a:solidFill>
-            <a:srgbClr val="D9931D"/>
+            <a:srgbClr val="A6A6A6"/>
           </a:solidFill>
           <a:ln w="12700">
             <a:solidFill>
-              <a:srgbClr val="D9931D"/>
+              <a:srgbClr val="A6A6A6"/>
             </a:solidFill>
             <a:prstDash val="solid"/>
           </a:ln>
@@ -10706,11 +10742,11 @@
             <a:avLst/>
           </a:prstGeom>
           <a:solidFill>
-            <a:srgbClr val="0E7C86"/>
+            <a:srgbClr val="404040"/>
           </a:solidFill>
           <a:ln w="12700">
             <a:solidFill>
-              <a:srgbClr val="0E7C86"/>
+              <a:srgbClr val="404040"/>
             </a:solidFill>
             <a:prstDash val="solid"/>
           </a:ln>
@@ -10743,7 +10779,7 @@
             <a:r>
               <a:rPr lang="en-US" sz="1400" b="1" dirty="0">
                 <a:solidFill>
-                  <a:schemeClr val="bg1"/>
+                  <a:srgbClr val="FFFFFF"/>
                 </a:solidFill>
               </a:rPr>
               <a:t>1</a:t>
@@ -10803,11 +10839,11 @@
             <a:avLst/>
           </a:prstGeom>
           <a:solidFill>
-            <a:srgbClr val="0E7C86"/>
+            <a:srgbClr val="404040"/>
           </a:solidFill>
           <a:ln w="12700">
             <a:solidFill>
-              <a:srgbClr val="0E7C86"/>
+              <a:srgbClr val="404040"/>
             </a:solidFill>
             <a:prstDash val="solid"/>
           </a:ln>
@@ -10840,7 +10876,7 @@
             <a:r>
               <a:rPr lang="en-US" sz="1400" b="1" dirty="0">
                 <a:solidFill>
-                  <a:schemeClr val="bg1"/>
+                  <a:srgbClr val="FFFFFF"/>
                 </a:solidFill>
               </a:rPr>
               <a:t>2</a:t>
@@ -10900,11 +10936,11 @@
             <a:avLst/>
           </a:prstGeom>
           <a:solidFill>
-            <a:srgbClr val="0E7C86"/>
+            <a:srgbClr val="404040"/>
           </a:solidFill>
           <a:ln w="12700">
             <a:solidFill>
-              <a:srgbClr val="0E7C86"/>
+              <a:srgbClr val="404040"/>
             </a:solidFill>
             <a:prstDash val="solid"/>
           </a:ln>
@@ -10937,7 +10973,7 @@
             <a:r>
               <a:rPr lang="en-US" sz="1400" b="1" dirty="0">
                 <a:solidFill>
-                  <a:schemeClr val="bg1"/>
+                  <a:srgbClr val="FFFFFF"/>
                 </a:solidFill>
               </a:rPr>
               <a:t>3</a:t>
@@ -10997,11 +11033,11 @@
             <a:avLst/>
           </a:prstGeom>
           <a:solidFill>
-            <a:srgbClr val="0E7C86"/>
+            <a:srgbClr val="404040"/>
           </a:solidFill>
           <a:ln w="12700">
             <a:solidFill>
-              <a:srgbClr val="0E7C86"/>
+              <a:srgbClr val="404040"/>
             </a:solidFill>
             <a:prstDash val="solid"/>
           </a:ln>
@@ -11034,7 +11070,7 @@
             <a:r>
               <a:rPr lang="en-US" sz="1400" b="1" dirty="0">
                 <a:solidFill>
-                  <a:schemeClr val="bg1"/>
+                  <a:srgbClr val="FFFFFF"/>
                 </a:solidFill>
               </a:rPr>
               <a:t>4</a:t>
@@ -11109,7 +11145,7 @@
             <a:lvl1pPr>
               <a:defRPr sz="1000">
                 <a:solidFill>
-                  <a:srgbClr val="4A6670"/>
+                  <a:srgbClr val="595959"/>
                 </a:solidFill>
               </a:defRPr>
             </a:lvl1pPr>
@@ -11240,11 +11276,11 @@
             </a:avLst>
           </a:prstGeom>
           <a:solidFill>
-            <a:srgbClr val="EEF3F8"/>
+            <a:srgbClr val="EDEDED"/>
           </a:solidFill>
           <a:ln w="12700">
             <a:solidFill>
-              <a:srgbClr val="EEF3F8"/>
+              <a:srgbClr val="EDEDED"/>
             </a:solidFill>
             <a:prstDash val="solid"/>
           </a:ln>
@@ -11265,11 +11301,11 @@
             <a:avLst/>
           </a:prstGeom>
           <a:solidFill>
-            <a:srgbClr val="B5413F"/>
+            <a:srgbClr val="4D4D4D"/>
           </a:solidFill>
           <a:ln w="12700">
             <a:solidFill>
-              <a:srgbClr val="B5413F"/>
+              <a:srgbClr val="4D4D4D"/>
             </a:solidFill>
             <a:prstDash val="solid"/>
           </a:ln>
@@ -11302,7 +11338,7 @@
             <a:r>
               <a:rPr lang="en-US" sz="1400" b="1" dirty="0">
                 <a:solidFill>
-                  <a:schemeClr val="bg1"/>
+                  <a:srgbClr val="FFFFFF"/>
                 </a:solidFill>
               </a:rPr>
               <a:t>1</a:t>
@@ -11364,11 +11400,11 @@
             </a:avLst>
           </a:prstGeom>
           <a:solidFill>
-            <a:srgbClr val="EEF3F8"/>
+            <a:srgbClr val="EDEDED"/>
           </a:solidFill>
           <a:ln w="12700">
             <a:solidFill>
-              <a:srgbClr val="EEF3F8"/>
+              <a:srgbClr val="EDEDED"/>
             </a:solidFill>
             <a:prstDash val="solid"/>
           </a:ln>
@@ -11389,11 +11425,11 @@
             <a:avLst/>
           </a:prstGeom>
           <a:solidFill>
-            <a:srgbClr val="B5413F"/>
+            <a:srgbClr val="4D4D4D"/>
           </a:solidFill>
           <a:ln w="12700">
             <a:solidFill>
-              <a:srgbClr val="B5413F"/>
+              <a:srgbClr val="4D4D4D"/>
             </a:solidFill>
             <a:prstDash val="solid"/>
           </a:ln>
@@ -11426,7 +11462,7 @@
             <a:r>
               <a:rPr lang="en-US" sz="1400" b="1" dirty="0">
                 <a:solidFill>
-                  <a:schemeClr val="bg1"/>
+                  <a:srgbClr val="FFFFFF"/>
                 </a:solidFill>
               </a:rPr>
               <a:t>2</a:t>
@@ -11524,11 +11560,11 @@
             </a:avLst>
           </a:prstGeom>
           <a:solidFill>
-            <a:srgbClr val="1F3A5F"/>
+            <a:srgbClr val="333333"/>
           </a:solidFill>
           <a:ln w="12700">
             <a:solidFill>
-              <a:srgbClr val="1F3A5F"/>
+              <a:srgbClr val="333333"/>
             </a:solidFill>
             <a:prstDash val="solid"/>
           </a:ln>
@@ -11658,7 +11694,7 @@
             <a:lvl1pPr>
               <a:defRPr sz="1000">
                 <a:solidFill>
-                  <a:srgbClr val="4A6670"/>
+                  <a:srgbClr val="595959"/>
                 </a:solidFill>
               </a:defRPr>
             </a:lvl1pPr>
@@ -11753,11 +11789,11 @@
             </a:avLst>
           </a:prstGeom>
           <a:solidFill>
-            <a:srgbClr val="1F3A5F"/>
+            <a:srgbClr val="333333"/>
           </a:solidFill>
           <a:ln w="12700">
             <a:solidFill>
-              <a:srgbClr val="1F3A5F"/>
+              <a:srgbClr val="333333"/>
             </a:solidFill>
             <a:prstDash val="solid"/>
           </a:ln>
@@ -11827,11 +11863,11 @@
             </a:avLst>
           </a:prstGeom>
           <a:solidFill>
-            <a:srgbClr val="1F3A5F"/>
+            <a:srgbClr val="333333"/>
           </a:solidFill>
           <a:ln w="12700">
             <a:solidFill>
-              <a:srgbClr val="1F3A5F"/>
+              <a:srgbClr val="333333"/>
             </a:solidFill>
             <a:prstDash val="solid"/>
           </a:ln>
@@ -11901,11 +11937,11 @@
             </a:avLst>
           </a:prstGeom>
           <a:solidFill>
-            <a:srgbClr val="1F3A5F"/>
+            <a:srgbClr val="333333"/>
           </a:solidFill>
           <a:ln w="12700">
             <a:solidFill>
-              <a:srgbClr val="1F3A5F"/>
+              <a:srgbClr val="333333"/>
             </a:solidFill>
             <a:prstDash val="solid"/>
           </a:ln>
@@ -12011,11 +12047,11 @@
             </a:avLst>
           </a:prstGeom>
           <a:solidFill>
-            <a:srgbClr val="0E7C86"/>
+            <a:srgbClr val="404040"/>
           </a:solidFill>
           <a:ln w="12700">
             <a:solidFill>
-              <a:srgbClr val="0E7C86"/>
+              <a:srgbClr val="404040"/>
             </a:solidFill>
             <a:prstDash val="solid"/>
           </a:ln>
@@ -12074,11 +12110,11 @@
             </a:avLst>
           </a:prstGeom>
           <a:solidFill>
-            <a:srgbClr val="0E7C86"/>
+            <a:srgbClr val="404040"/>
           </a:solidFill>
           <a:ln w="12700">
             <a:solidFill>
-              <a:srgbClr val="0E7C86"/>
+              <a:srgbClr val="404040"/>
             </a:solidFill>
             <a:prstDash val="solid"/>
           </a:ln>
@@ -12137,11 +12173,11 @@
             </a:avLst>
           </a:prstGeom>
           <a:solidFill>
-            <a:srgbClr val="0E7C86"/>
+            <a:srgbClr val="404040"/>
           </a:solidFill>
           <a:ln w="12700">
             <a:solidFill>
-              <a:srgbClr val="0E7C86"/>
+              <a:srgbClr val="404040"/>
             </a:solidFill>
             <a:prstDash val="solid"/>
           </a:ln>
@@ -12200,11 +12236,11 @@
             </a:avLst>
           </a:prstGeom>
           <a:solidFill>
-            <a:srgbClr val="0E7C86"/>
+            <a:srgbClr val="404040"/>
           </a:solidFill>
           <a:ln w="12700">
             <a:solidFill>
-              <a:srgbClr val="0E7C86"/>
+              <a:srgbClr val="404040"/>
             </a:solidFill>
             <a:prstDash val="solid"/>
           </a:ln>
@@ -12263,11 +12299,11 @@
             </a:avLst>
           </a:prstGeom>
           <a:solidFill>
-            <a:srgbClr val="0E7C86"/>
+            <a:srgbClr val="404040"/>
           </a:solidFill>
           <a:ln w="12700">
             <a:solidFill>
-              <a:srgbClr val="0E7C86"/>
+              <a:srgbClr val="404040"/>
             </a:solidFill>
             <a:prstDash val="solid"/>
           </a:ln>
@@ -12326,11 +12362,11 @@
             </a:avLst>
           </a:prstGeom>
           <a:solidFill>
-            <a:srgbClr val="0E7C86"/>
+            <a:srgbClr val="404040"/>
           </a:solidFill>
           <a:ln w="12700">
             <a:solidFill>
-              <a:srgbClr val="0E7C86"/>
+              <a:srgbClr val="404040"/>
             </a:solidFill>
             <a:prstDash val="solid"/>
           </a:ln>
@@ -12389,11 +12425,11 @@
             </a:avLst>
           </a:prstGeom>
           <a:solidFill>
-            <a:srgbClr val="0E7C86"/>
+            <a:srgbClr val="404040"/>
           </a:solidFill>
           <a:ln w="12700">
             <a:solidFill>
-              <a:srgbClr val="0E7C86"/>
+              <a:srgbClr val="404040"/>
             </a:solidFill>
             <a:prstDash val="solid"/>
           </a:ln>
@@ -12452,11 +12488,11 @@
             </a:avLst>
           </a:prstGeom>
           <a:solidFill>
-            <a:srgbClr val="0E7C86"/>
+            <a:srgbClr val="404040"/>
           </a:solidFill>
           <a:ln w="12700">
             <a:solidFill>
-              <a:srgbClr val="0E7C86"/>
+              <a:srgbClr val="404040"/>
             </a:solidFill>
             <a:prstDash val="solid"/>
           </a:ln>
@@ -12515,11 +12551,11 @@
             </a:avLst>
           </a:prstGeom>
           <a:solidFill>
-            <a:srgbClr val="0E7C86"/>
+            <a:srgbClr val="404040"/>
           </a:solidFill>
           <a:ln w="12700">
             <a:solidFill>
-              <a:srgbClr val="0E7C86"/>
+              <a:srgbClr val="404040"/>
             </a:solidFill>
             <a:prstDash val="solid"/>
           </a:ln>
@@ -12578,11 +12614,11 @@
             </a:avLst>
           </a:prstGeom>
           <a:solidFill>
-            <a:srgbClr val="0E7C86"/>
+            <a:srgbClr val="404040"/>
           </a:solidFill>
           <a:ln w="12700">
             <a:solidFill>
-              <a:srgbClr val="0E7C86"/>
+              <a:srgbClr val="404040"/>
             </a:solidFill>
             <a:prstDash val="solid"/>
           </a:ln>
@@ -12641,11 +12677,11 @@
             </a:avLst>
           </a:prstGeom>
           <a:solidFill>
-            <a:srgbClr val="0E7C86"/>
+            <a:srgbClr val="404040"/>
           </a:solidFill>
           <a:ln w="12700">
             <a:solidFill>
-              <a:srgbClr val="0E7C86"/>
+              <a:srgbClr val="404040"/>
             </a:solidFill>
             <a:prstDash val="solid"/>
           </a:ln>
@@ -12704,11 +12740,11 @@
             </a:avLst>
           </a:prstGeom>
           <a:solidFill>
-            <a:srgbClr val="0E7C86"/>
+            <a:srgbClr val="404040"/>
           </a:solidFill>
           <a:ln w="12700">
             <a:solidFill>
-              <a:srgbClr val="0E7C86"/>
+              <a:srgbClr val="404040"/>
             </a:solidFill>
             <a:prstDash val="solid"/>
           </a:ln>
@@ -12780,7 +12816,7 @@
             <a:lvl1pPr>
               <a:defRPr sz="1000">
                 <a:solidFill>
-                  <a:srgbClr val="9BA7B4"/>
+                  <a:srgbClr val="BFBFBF"/>
                 </a:solidFill>
               </a:defRPr>
             </a:lvl1pPr>
@@ -12873,11 +12909,11 @@
             <a:avLst/>
           </a:prstGeom>
           <a:solidFill>
-            <a:srgbClr val="D9931D"/>
+            <a:srgbClr val="A6A6A6"/>
           </a:solidFill>
           <a:ln w="12700">
             <a:solidFill>
-              <a:srgbClr val="D9931D"/>
+              <a:srgbClr val="A6A6A6"/>
             </a:solidFill>
             <a:prstDash val="solid"/>
           </a:ln>
@@ -12960,11 +12996,11 @@
             </a:avLst>
           </a:prstGeom>
           <a:solidFill>
-            <a:srgbClr val="1F3A5F"/>
+            <a:srgbClr val="333333"/>
           </a:solidFill>
           <a:ln w="12700">
             <a:solidFill>
-              <a:srgbClr val="1F3A5F"/>
+              <a:srgbClr val="333333"/>
             </a:solidFill>
             <a:prstDash val="solid"/>
           </a:ln>
@@ -13059,11 +13095,11 @@
             </a:avLst>
           </a:prstGeom>
           <a:solidFill>
-            <a:srgbClr val="1F3A5F"/>
+            <a:srgbClr val="333333"/>
           </a:solidFill>
           <a:ln w="12700">
             <a:solidFill>
-              <a:srgbClr val="1F3A5F"/>
+              <a:srgbClr val="333333"/>
             </a:solidFill>
             <a:prstDash val="solid"/>
           </a:ln>
@@ -13158,11 +13194,11 @@
             </a:avLst>
           </a:prstGeom>
           <a:solidFill>
-            <a:srgbClr val="1F3A5F"/>
+            <a:srgbClr val="333333"/>
           </a:solidFill>
           <a:ln w="12700">
             <a:solidFill>
-              <a:srgbClr val="1F3A5F"/>
+              <a:srgbClr val="333333"/>
             </a:solidFill>
             <a:prstDash val="solid"/>
           </a:ln>
@@ -13306,7 +13342,7 @@
             <a:lvl1pPr>
               <a:defRPr sz="1000">
                 <a:solidFill>
-                  <a:srgbClr val="9BA7B4"/>
+                  <a:srgbClr val="BFBFBF"/>
                 </a:solidFill>
               </a:defRPr>
             </a:lvl1pPr>
@@ -13401,11 +13437,11 @@
             </a:avLst>
           </a:prstGeom>
           <a:solidFill>
-            <a:srgbClr val="EEF3F8"/>
+            <a:srgbClr val="EDEDED"/>
           </a:solidFill>
           <a:ln w="12700">
             <a:solidFill>
-              <a:srgbClr val="EEF3F8"/>
+              <a:srgbClr val="EDEDED"/>
             </a:solidFill>
             <a:prstDash val="solid"/>
           </a:ln>
@@ -13478,11 +13514,11 @@
             </a:avLst>
           </a:prstGeom>
           <a:solidFill>
-            <a:srgbClr val="EEF3F8"/>
+            <a:srgbClr val="EDEDED"/>
           </a:solidFill>
           <a:ln w="12700">
             <a:solidFill>
-              <a:srgbClr val="EEF3F8"/>
+              <a:srgbClr val="EDEDED"/>
             </a:solidFill>
             <a:prstDash val="solid"/>
           </a:ln>
@@ -13555,11 +13591,11 @@
             </a:avLst>
           </a:prstGeom>
           <a:solidFill>
-            <a:srgbClr val="1F3A5F"/>
+            <a:srgbClr val="333333"/>
           </a:solidFill>
           <a:ln w="12700">
             <a:solidFill>
-              <a:srgbClr val="1F3A5F"/>
+              <a:srgbClr val="333333"/>
             </a:solidFill>
             <a:prstDash val="solid"/>
           </a:ln>
@@ -13678,7 +13714,7 @@
             <a:lvl1pPr>
               <a:defRPr sz="1000">
                 <a:solidFill>
-                  <a:srgbClr val="4A6670"/>
+                  <a:srgbClr val="595959"/>
                 </a:solidFill>
               </a:defRPr>
             </a:lvl1pPr>
@@ -13773,11 +13809,11 @@
             </a:avLst>
           </a:prstGeom>
           <a:solidFill>
-            <a:srgbClr val="EEF3F8"/>
+            <a:srgbClr val="EDEDED"/>
           </a:solidFill>
           <a:ln w="12700">
             <a:solidFill>
-              <a:srgbClr val="EEF3F8"/>
+              <a:srgbClr val="EDEDED"/>
             </a:solidFill>
             <a:prstDash val="solid"/>
           </a:ln>
@@ -13798,11 +13834,11 @@
             <a:avLst/>
           </a:prstGeom>
           <a:solidFill>
-            <a:srgbClr val="D9931D"/>
+            <a:srgbClr val="A6A6A6"/>
           </a:solidFill>
           <a:ln w="12700">
             <a:solidFill>
-              <a:srgbClr val="D9931D"/>
+              <a:srgbClr val="A6A6A6"/>
             </a:solidFill>
             <a:prstDash val="solid"/>
           </a:ln>
@@ -13957,11 +13993,11 @@
             </a:avLst>
           </a:prstGeom>
           <a:solidFill>
-            <a:srgbClr val="EEF3F8"/>
+            <a:srgbClr val="EDEDED"/>
           </a:solidFill>
           <a:ln w="12700">
             <a:solidFill>
-              <a:srgbClr val="EEF3F8"/>
+              <a:srgbClr val="EDEDED"/>
             </a:solidFill>
             <a:prstDash val="solid"/>
           </a:ln>
@@ -13982,11 +14018,11 @@
             <a:avLst/>
           </a:prstGeom>
           <a:solidFill>
-            <a:srgbClr val="D9931D"/>
+            <a:srgbClr val="A6A6A6"/>
           </a:solidFill>
           <a:ln w="12700">
             <a:solidFill>
-              <a:srgbClr val="D9931D"/>
+              <a:srgbClr val="A6A6A6"/>
             </a:solidFill>
             <a:prstDash val="solid"/>
           </a:ln>
@@ -14141,11 +14177,11 @@
             </a:avLst>
           </a:prstGeom>
           <a:solidFill>
-            <a:srgbClr val="EEF3F8"/>
+            <a:srgbClr val="EDEDED"/>
           </a:solidFill>
           <a:ln w="12700">
             <a:solidFill>
-              <a:srgbClr val="EEF3F8"/>
+              <a:srgbClr val="EDEDED"/>
             </a:solidFill>
             <a:prstDash val="solid"/>
           </a:ln>
@@ -14166,11 +14202,11 @@
             <a:avLst/>
           </a:prstGeom>
           <a:solidFill>
-            <a:srgbClr val="D9931D"/>
+            <a:srgbClr val="A6A6A6"/>
           </a:solidFill>
           <a:ln w="12700">
             <a:solidFill>
-              <a:srgbClr val="D9931D"/>
+              <a:srgbClr val="A6A6A6"/>
             </a:solidFill>
             <a:prstDash val="solid"/>
           </a:ln>
@@ -14338,7 +14374,7 @@
             <a:lvl1pPr>
               <a:defRPr sz="1000">
                 <a:solidFill>
-                  <a:srgbClr val="4A6670"/>
+                  <a:srgbClr val="595959"/>
                 </a:solidFill>
               </a:defRPr>
             </a:lvl1pPr>
@@ -14431,11 +14467,11 @@
             <a:avLst/>
           </a:prstGeom>
           <a:solidFill>
-            <a:srgbClr val="D9931D"/>
+            <a:srgbClr val="A6A6A6"/>
           </a:solidFill>
           <a:ln w="12700">
             <a:solidFill>
-              <a:srgbClr val="D9931D"/>
+              <a:srgbClr val="A6A6A6"/>
             </a:solidFill>
             <a:prstDash val="solid"/>
           </a:ln>
@@ -14468,7 +14504,7 @@
             <a:r>
               <a:rPr lang="en-US" sz="1400" b="1" dirty="0">
                 <a:solidFill>
-                  <a:schemeClr val="bg1"/>
+                  <a:srgbClr val="000000"/>
                 </a:solidFill>
               </a:rPr>
               <a:t>1</a:t>
@@ -14528,11 +14564,11 @@
             <a:avLst/>
           </a:prstGeom>
           <a:solidFill>
-            <a:srgbClr val="D9931D"/>
+            <a:srgbClr val="A6A6A6"/>
           </a:solidFill>
           <a:ln w="12700">
             <a:solidFill>
-              <a:srgbClr val="D9931D"/>
+              <a:srgbClr val="A6A6A6"/>
             </a:solidFill>
             <a:prstDash val="solid"/>
           </a:ln>
@@ -14565,7 +14601,7 @@
             <a:r>
               <a:rPr lang="en-US" sz="1400" b="1" dirty="0">
                 <a:solidFill>
-                  <a:schemeClr val="bg1"/>
+                  <a:srgbClr val="000000"/>
                 </a:solidFill>
               </a:rPr>
               <a:t>2</a:t>
@@ -14625,11 +14661,11 @@
             <a:avLst/>
           </a:prstGeom>
           <a:solidFill>
-            <a:srgbClr val="D9931D"/>
+            <a:srgbClr val="A6A6A6"/>
           </a:solidFill>
           <a:ln w="12700">
             <a:solidFill>
-              <a:srgbClr val="D9931D"/>
+              <a:srgbClr val="A6A6A6"/>
             </a:solidFill>
             <a:prstDash val="solid"/>
           </a:ln>
@@ -14662,7 +14698,7 @@
             <a:r>
               <a:rPr lang="en-US" sz="1400" b="1" dirty="0">
                 <a:solidFill>
-                  <a:schemeClr val="bg1"/>
+                  <a:srgbClr val="000000"/>
                 </a:solidFill>
               </a:rPr>
               <a:t>3</a:t>
@@ -14722,11 +14758,11 @@
             <a:avLst/>
           </a:prstGeom>
           <a:solidFill>
-            <a:srgbClr val="D9931D"/>
+            <a:srgbClr val="A6A6A6"/>
           </a:solidFill>
           <a:ln w="12700">
             <a:solidFill>
-              <a:srgbClr val="D9931D"/>
+              <a:srgbClr val="A6A6A6"/>
             </a:solidFill>
             <a:prstDash val="solid"/>
           </a:ln>
@@ -14759,7 +14795,7 @@
             <a:r>
               <a:rPr lang="en-US" sz="1400" b="1" dirty="0">
                 <a:solidFill>
-                  <a:schemeClr val="bg1"/>
+                  <a:srgbClr val="000000"/>
                 </a:solidFill>
               </a:rPr>
               <a:t>4</a:t>
@@ -14819,11 +14855,11 @@
             <a:avLst/>
           </a:prstGeom>
           <a:solidFill>
-            <a:srgbClr val="D9931D"/>
+            <a:srgbClr val="A6A6A6"/>
           </a:solidFill>
           <a:ln w="12700">
             <a:solidFill>
-              <a:srgbClr val="D9931D"/>
+              <a:srgbClr val="A6A6A6"/>
             </a:solidFill>
             <a:prstDash val="solid"/>
           </a:ln>
@@ -14856,7 +14892,7 @@
             <a:r>
               <a:rPr lang="en-US" sz="1400" b="1" dirty="0">
                 <a:solidFill>
-                  <a:schemeClr val="bg1"/>
+                  <a:srgbClr val="000000"/>
                 </a:solidFill>
               </a:rPr>
               <a:t>5</a:t>
@@ -14931,7 +14967,7 @@
             <a:lvl1pPr>
               <a:defRPr sz="1000">
                 <a:solidFill>
-                  <a:srgbClr val="9BA7B4"/>
+                  <a:srgbClr val="BFBFBF"/>
                 </a:solidFill>
               </a:defRPr>
             </a:lvl1pPr>
@@ -15026,11 +15062,11 @@
             </a:avLst>
           </a:prstGeom>
           <a:solidFill>
-            <a:srgbClr val="EEF3F8"/>
+            <a:srgbClr val="EDEDED"/>
           </a:solidFill>
           <a:ln w="12700">
             <a:solidFill>
-              <a:srgbClr val="EEF3F8"/>
+              <a:srgbClr val="EDEDED"/>
             </a:solidFill>
             <a:prstDash val="solid"/>
           </a:ln>
@@ -15051,11 +15087,11 @@
             <a:avLst/>
           </a:prstGeom>
           <a:solidFill>
-            <a:srgbClr val="0E7C86"/>
+            <a:srgbClr val="404040"/>
           </a:solidFill>
           <a:ln w="12700">
             <a:solidFill>
-              <a:srgbClr val="0E7C86"/>
+              <a:srgbClr val="404040"/>
             </a:solidFill>
             <a:prstDash val="solid"/>
           </a:ln>
@@ -15250,11 +15286,11 @@
             </a:avLst>
           </a:prstGeom>
           <a:solidFill>
-            <a:srgbClr val="1F3A5F"/>
+            <a:srgbClr val="333333"/>
           </a:solidFill>
           <a:ln w="12700">
             <a:solidFill>
-              <a:srgbClr val="1F3A5F"/>
+              <a:srgbClr val="333333"/>
             </a:solidFill>
             <a:prstDash val="solid"/>
           </a:ln>
@@ -15331,7 +15367,7 @@
           </a:solidFill>
           <a:ln w="9525">
             <a:solidFill>
-              <a:srgbClr val="9BA7B4"/>
+              <a:srgbClr val="BFBFBF"/>
             </a:solidFill>
             <a:prstDash val="solid"/>
           </a:ln>
@@ -15431,7 +15467,7 @@
             <a:lvl1pPr>
               <a:defRPr sz="1000">
                 <a:solidFill>
-                  <a:srgbClr val="4A6670"/>
+                  <a:srgbClr val="595959"/>
                 </a:solidFill>
               </a:defRPr>
             </a:lvl1pPr>
@@ -15687,7 +15723,7 @@
             <a:lvl1pPr>
               <a:defRPr sz="1000">
                 <a:solidFill>
-                  <a:srgbClr val="4A6670"/>
+                  <a:srgbClr val="595959"/>
                 </a:solidFill>
               </a:defRPr>
             </a:lvl1pPr>
@@ -15780,11 +15816,11 @@
             <a:avLst/>
           </a:prstGeom>
           <a:solidFill>
-            <a:srgbClr val="0E7C86"/>
+            <a:srgbClr val="404040"/>
           </a:solidFill>
           <a:ln w="12700">
             <a:solidFill>
-              <a:srgbClr val="0E7C86"/>
+              <a:srgbClr val="404040"/>
             </a:solidFill>
             <a:prstDash val="solid"/>
           </a:ln>
@@ -15876,11 +15912,11 @@
             <a:avLst/>
           </a:prstGeom>
           <a:solidFill>
-            <a:srgbClr val="0E7C86"/>
+            <a:srgbClr val="404040"/>
           </a:solidFill>
           <a:ln w="12700">
             <a:solidFill>
-              <a:srgbClr val="0E7C86"/>
+              <a:srgbClr val="404040"/>
             </a:solidFill>
             <a:prstDash val="solid"/>
           </a:ln>
@@ -15972,11 +16008,11 @@
             <a:avLst/>
           </a:prstGeom>
           <a:solidFill>
-            <a:srgbClr val="0E7C86"/>
+            <a:srgbClr val="404040"/>
           </a:solidFill>
           <a:ln w="12700">
             <a:solidFill>
-              <a:srgbClr val="0E7C86"/>
+              <a:srgbClr val="404040"/>
             </a:solidFill>
             <a:prstDash val="solid"/>
           </a:ln>
@@ -16068,11 +16104,11 @@
             <a:avLst/>
           </a:prstGeom>
           <a:solidFill>
-            <a:srgbClr val="0E7C86"/>
+            <a:srgbClr val="404040"/>
           </a:solidFill>
           <a:ln w="12700">
             <a:solidFill>
-              <a:srgbClr val="0E7C86"/>
+              <a:srgbClr val="404040"/>
             </a:solidFill>
             <a:prstDash val="solid"/>
           </a:ln>
@@ -16164,11 +16200,11 @@
             <a:avLst/>
           </a:prstGeom>
           <a:solidFill>
-            <a:srgbClr val="0E7C86"/>
+            <a:srgbClr val="404040"/>
           </a:solidFill>
           <a:ln w="12700">
             <a:solidFill>
-              <a:srgbClr val="0E7C86"/>
+              <a:srgbClr val="404040"/>
             </a:solidFill>
             <a:prstDash val="solid"/>
           </a:ln>
@@ -16260,11 +16296,11 @@
             <a:avLst/>
           </a:prstGeom>
           <a:solidFill>
-            <a:srgbClr val="0E7C86"/>
+            <a:srgbClr val="404040"/>
           </a:solidFill>
           <a:ln w="12700">
             <a:solidFill>
-              <a:srgbClr val="0E7C86"/>
+              <a:srgbClr val="404040"/>
             </a:solidFill>
             <a:prstDash val="solid"/>
           </a:ln>
@@ -16371,7 +16407,7 @@
             <a:lvl1pPr>
               <a:defRPr sz="1000">
                 <a:solidFill>
-                  <a:srgbClr val="4A6670"/>
+                  <a:srgbClr val="595959"/>
                 </a:solidFill>
               </a:defRPr>
             </a:lvl1pPr>
@@ -16466,11 +16502,11 @@
             </a:avLst>
           </a:prstGeom>
           <a:solidFill>
-            <a:srgbClr val="EEF3F8"/>
+            <a:srgbClr val="EDEDED"/>
           </a:solidFill>
           <a:ln w="12700">
             <a:solidFill>
-              <a:srgbClr val="EEF3F8"/>
+              <a:srgbClr val="EDEDED"/>
             </a:solidFill>
             <a:prstDash val="solid"/>
           </a:ln>
@@ -16544,7 +16580,7 @@
           </a:solidFill>
           <a:ln w="9525">
             <a:solidFill>
-              <a:srgbClr val="9BA7B4"/>
+              <a:srgbClr val="BFBFBF"/>
             </a:solidFill>
             <a:prstDash val="solid"/>
           </a:ln>
@@ -16626,11 +16662,11 @@
             <a:avLst/>
           </a:prstGeom>
           <a:solidFill>
-            <a:srgbClr val="D9931D"/>
+            <a:srgbClr val="A6A6A6"/>
           </a:solidFill>
           <a:ln w="12700">
             <a:solidFill>
-              <a:srgbClr val="D9931D"/>
+              <a:srgbClr val="A6A6A6"/>
             </a:solidFill>
             <a:prstDash val="solid"/>
           </a:ln>
@@ -16725,11 +16761,11 @@
             <a:avLst/>
           </a:prstGeom>
           <a:solidFill>
-            <a:srgbClr val="D9931D"/>
+            <a:srgbClr val="A6A6A6"/>
           </a:solidFill>
           <a:ln w="12700">
             <a:solidFill>
-              <a:srgbClr val="D9931D"/>
+              <a:srgbClr val="A6A6A6"/>
             </a:solidFill>
             <a:prstDash val="solid"/>
           </a:ln>
@@ -16824,11 +16860,11 @@
             <a:avLst/>
           </a:prstGeom>
           <a:solidFill>
-            <a:srgbClr val="D9931D"/>
+            <a:srgbClr val="A6A6A6"/>
           </a:solidFill>
           <a:ln w="12700">
             <a:solidFill>
-              <a:srgbClr val="D9931D"/>
+              <a:srgbClr val="A6A6A6"/>
             </a:solidFill>
             <a:prstDash val="solid"/>
           </a:ln>
@@ -16974,7 +17010,7 @@
             <a:lvl1pPr>
               <a:defRPr sz="1000">
                 <a:solidFill>
-                  <a:srgbClr val="4A6670"/>
+                  <a:srgbClr val="595959"/>
                 </a:solidFill>
               </a:defRPr>
             </a:lvl1pPr>
@@ -17069,11 +17105,11 @@
             </a:avLst>
           </a:prstGeom>
           <a:solidFill>
-            <a:srgbClr val="EEF3F8"/>
+            <a:srgbClr val="EDEDED"/>
           </a:solidFill>
           <a:ln w="12700">
             <a:solidFill>
-              <a:srgbClr val="EEF3F8"/>
+              <a:srgbClr val="EDEDED"/>
             </a:solidFill>
             <a:prstDash val="solid"/>
           </a:ln>
@@ -17094,11 +17130,11 @@
             <a:avLst/>
           </a:prstGeom>
           <a:solidFill>
-            <a:srgbClr val="0E7C86"/>
+            <a:srgbClr val="404040"/>
           </a:solidFill>
           <a:ln w="12700">
             <a:solidFill>
-              <a:srgbClr val="0E7C86"/>
+              <a:srgbClr val="404040"/>
             </a:solidFill>
             <a:prstDash val="solid"/>
           </a:ln>
@@ -17264,11 +17300,11 @@
             </a:avLst>
           </a:prstGeom>
           <a:solidFill>
-            <a:srgbClr val="EEF3F8"/>
+            <a:srgbClr val="EDEDED"/>
           </a:solidFill>
           <a:ln w="12700">
             <a:solidFill>
-              <a:srgbClr val="EEF3F8"/>
+              <a:srgbClr val="EDEDED"/>
             </a:solidFill>
             <a:prstDash val="solid"/>
           </a:ln>
@@ -17289,11 +17325,11 @@
             <a:avLst/>
           </a:prstGeom>
           <a:solidFill>
-            <a:srgbClr val="5B7DB1"/>
+            <a:srgbClr val="737373"/>
           </a:solidFill>
           <a:ln w="12700">
             <a:solidFill>
-              <a:srgbClr val="5B7DB1"/>
+              <a:srgbClr val="737373"/>
             </a:solidFill>
             <a:prstDash val="solid"/>
           </a:ln>
@@ -17459,11 +17495,11 @@
             </a:avLst>
           </a:prstGeom>
           <a:solidFill>
-            <a:srgbClr val="EEF3F8"/>
+            <a:srgbClr val="EDEDED"/>
           </a:solidFill>
           <a:ln w="12700">
             <a:solidFill>
-              <a:srgbClr val="EEF3F8"/>
+              <a:srgbClr val="EDEDED"/>
             </a:solidFill>
             <a:prstDash val="solid"/>
           </a:ln>
@@ -17484,11 +17520,11 @@
             <a:avLst/>
           </a:prstGeom>
           <a:solidFill>
-            <a:srgbClr val="4A6670"/>
+            <a:srgbClr val="595959"/>
           </a:solidFill>
           <a:ln w="12700">
             <a:solidFill>
-              <a:srgbClr val="4A6670"/>
+              <a:srgbClr val="595959"/>
             </a:solidFill>
             <a:prstDash val="solid"/>
           </a:ln>
@@ -17667,7 +17703,7 @@
             <a:lvl1pPr>
               <a:defRPr sz="1000">
                 <a:solidFill>
-                  <a:srgbClr val="4A6670"/>
+                  <a:srgbClr val="595959"/>
                 </a:solidFill>
               </a:defRPr>
             </a:lvl1pPr>
@@ -17762,11 +17798,11 @@
             </a:avLst>
           </a:prstGeom>
           <a:solidFill>
-            <a:srgbClr val="EEF3F8"/>
+            <a:srgbClr val="EDEDED"/>
           </a:solidFill>
           <a:ln w="12700">
             <a:solidFill>
-              <a:srgbClr val="EEF3F8"/>
+              <a:srgbClr val="EDEDED"/>
             </a:solidFill>
             <a:prstDash val="solid"/>
           </a:ln>
@@ -17787,11 +17823,11 @@
             <a:avLst/>
           </a:prstGeom>
           <a:solidFill>
-            <a:srgbClr val="0E7C86"/>
+            <a:srgbClr val="404040"/>
           </a:solidFill>
           <a:ln w="12700">
             <a:solidFill>
-              <a:srgbClr val="0E7C86"/>
+              <a:srgbClr val="404040"/>
             </a:solidFill>
             <a:prstDash val="solid"/>
           </a:ln>
@@ -17924,11 +17960,11 @@
             </a:avLst>
           </a:prstGeom>
           <a:solidFill>
-            <a:srgbClr val="EEF3F8"/>
+            <a:srgbClr val="EDEDED"/>
           </a:solidFill>
           <a:ln w="12700">
             <a:solidFill>
-              <a:srgbClr val="EEF3F8"/>
+              <a:srgbClr val="EDEDED"/>
             </a:solidFill>
             <a:prstDash val="solid"/>
           </a:ln>
@@ -17949,11 +17985,11 @@
             <a:avLst/>
           </a:prstGeom>
           <a:solidFill>
-            <a:srgbClr val="0E7C86"/>
+            <a:srgbClr val="404040"/>
           </a:solidFill>
           <a:ln w="12700">
             <a:solidFill>
-              <a:srgbClr val="0E7C86"/>
+              <a:srgbClr val="404040"/>
             </a:solidFill>
             <a:prstDash val="solid"/>
           </a:ln>
@@ -18086,11 +18122,11 @@
             </a:avLst>
           </a:prstGeom>
           <a:solidFill>
-            <a:srgbClr val="EEF3F8"/>
+            <a:srgbClr val="EDEDED"/>
           </a:solidFill>
           <a:ln w="12700">
             <a:solidFill>
-              <a:srgbClr val="EEF3F8"/>
+              <a:srgbClr val="EDEDED"/>
             </a:solidFill>
             <a:prstDash val="solid"/>
           </a:ln>
@@ -18111,11 +18147,11 @@
             <a:avLst/>
           </a:prstGeom>
           <a:solidFill>
-            <a:srgbClr val="0E7C86"/>
+            <a:srgbClr val="404040"/>
           </a:solidFill>
           <a:ln w="12700">
             <a:solidFill>
-              <a:srgbClr val="0E7C86"/>
+              <a:srgbClr val="404040"/>
             </a:solidFill>
             <a:prstDash val="solid"/>
           </a:ln>
@@ -18248,11 +18284,11 @@
             </a:avLst>
           </a:prstGeom>
           <a:solidFill>
-            <a:srgbClr val="EEF3F8"/>
+            <a:srgbClr val="EDEDED"/>
           </a:solidFill>
           <a:ln w="12700">
             <a:solidFill>
-              <a:srgbClr val="EEF3F8"/>
+              <a:srgbClr val="EDEDED"/>
             </a:solidFill>
             <a:prstDash val="solid"/>
           </a:ln>
@@ -18273,11 +18309,11 @@
             <a:avLst/>
           </a:prstGeom>
           <a:solidFill>
-            <a:srgbClr val="0E7C86"/>
+            <a:srgbClr val="404040"/>
           </a:solidFill>
           <a:ln w="12700">
             <a:solidFill>
-              <a:srgbClr val="0E7C86"/>
+              <a:srgbClr val="404040"/>
             </a:solidFill>
             <a:prstDash val="solid"/>
           </a:ln>
@@ -18459,7 +18495,7 @@
             <a:lvl1pPr>
               <a:defRPr sz="1000">
                 <a:solidFill>
-                  <a:srgbClr val="4A6670"/>
+                  <a:srgbClr val="595959"/>
                 </a:solidFill>
               </a:defRPr>
             </a:lvl1pPr>
@@ -18590,11 +18626,11 @@
             </a:avLst>
           </a:prstGeom>
           <a:solidFill>
-            <a:srgbClr val="1F3A5F"/>
+            <a:srgbClr val="333333"/>
           </a:solidFill>
           <a:ln w="12700">
             <a:solidFill>
-              <a:srgbClr val="1F3A5F"/>
+              <a:srgbClr val="333333"/>
             </a:solidFill>
             <a:prstDash val="solid"/>
           </a:ln>
@@ -18615,11 +18651,11 @@
             <a:avLst/>
           </a:prstGeom>
           <a:solidFill>
-            <a:srgbClr val="D9931D"/>
+            <a:srgbClr val="A6A6A6"/>
           </a:solidFill>
           <a:ln w="12700">
             <a:solidFill>
-              <a:srgbClr val="D9931D"/>
+              <a:srgbClr val="A6A6A6"/>
             </a:solidFill>
             <a:prstDash val="solid"/>
           </a:ln>
@@ -18652,7 +18688,7 @@
             <a:r>
               <a:rPr lang="en-US" sz="1400" b="1" dirty="0">
                 <a:solidFill>
-                  <a:schemeClr val="bg1"/>
+                  <a:srgbClr val="000000"/>
                 </a:solidFill>
               </a:rPr>
               <a:t>1</a:t>
@@ -18750,11 +18786,11 @@
             </a:avLst>
           </a:prstGeom>
           <a:solidFill>
-            <a:srgbClr val="1F3A5F"/>
+            <a:srgbClr val="333333"/>
           </a:solidFill>
           <a:ln w="12700">
             <a:solidFill>
-              <a:srgbClr val="1F3A5F"/>
+              <a:srgbClr val="333333"/>
             </a:solidFill>
             <a:prstDash val="solid"/>
           </a:ln>
@@ -18775,11 +18811,11 @@
             <a:avLst/>
           </a:prstGeom>
           <a:solidFill>
-            <a:srgbClr val="D9931D"/>
+            <a:srgbClr val="A6A6A6"/>
           </a:solidFill>
           <a:ln w="12700">
             <a:solidFill>
-              <a:srgbClr val="D9931D"/>
+              <a:srgbClr val="A6A6A6"/>
             </a:solidFill>
             <a:prstDash val="solid"/>
           </a:ln>
@@ -18812,7 +18848,7 @@
             <a:r>
               <a:rPr lang="en-US" sz="1400" b="1" dirty="0">
                 <a:solidFill>
-                  <a:schemeClr val="bg1"/>
+                  <a:srgbClr val="000000"/>
                 </a:solidFill>
               </a:rPr>
               <a:t>2</a:t>
@@ -18910,11 +18946,11 @@
             </a:avLst>
           </a:prstGeom>
           <a:solidFill>
-            <a:srgbClr val="1F3A5F"/>
+            <a:srgbClr val="333333"/>
           </a:solidFill>
           <a:ln w="12700">
             <a:solidFill>
-              <a:srgbClr val="1F3A5F"/>
+              <a:srgbClr val="333333"/>
             </a:solidFill>
             <a:prstDash val="solid"/>
           </a:ln>
@@ -18935,11 +18971,11 @@
             <a:avLst/>
           </a:prstGeom>
           <a:solidFill>
-            <a:srgbClr val="D9931D"/>
+            <a:srgbClr val="A6A6A6"/>
           </a:solidFill>
           <a:ln w="12700">
             <a:solidFill>
-              <a:srgbClr val="D9931D"/>
+              <a:srgbClr val="A6A6A6"/>
             </a:solidFill>
             <a:prstDash val="solid"/>
           </a:ln>
@@ -18972,7 +19008,7 @@
             <a:r>
               <a:rPr lang="en-US" sz="1400" b="1" dirty="0">
                 <a:solidFill>
-                  <a:schemeClr val="bg1"/>
+                  <a:srgbClr val="000000"/>
                 </a:solidFill>
               </a:rPr>
               <a:t>3</a:t>
@@ -19070,11 +19106,11 @@
             </a:avLst>
           </a:prstGeom>
           <a:solidFill>
-            <a:srgbClr val="1F3A5F"/>
+            <a:srgbClr val="333333"/>
           </a:solidFill>
           <a:ln w="12700">
             <a:solidFill>
-              <a:srgbClr val="1F3A5F"/>
+              <a:srgbClr val="333333"/>
             </a:solidFill>
             <a:prstDash val="solid"/>
           </a:ln>
@@ -19095,11 +19131,11 @@
             <a:avLst/>
           </a:prstGeom>
           <a:solidFill>
-            <a:srgbClr val="D9931D"/>
+            <a:srgbClr val="A6A6A6"/>
           </a:solidFill>
           <a:ln w="12700">
             <a:solidFill>
-              <a:srgbClr val="D9931D"/>
+              <a:srgbClr val="A6A6A6"/>
             </a:solidFill>
             <a:prstDash val="solid"/>
           </a:ln>
@@ -19132,7 +19168,7 @@
             <a:r>
               <a:rPr lang="en-US" sz="1400" b="1" dirty="0">
                 <a:solidFill>
-                  <a:schemeClr val="bg1"/>
+                  <a:srgbClr val="000000"/>
                 </a:solidFill>
               </a:rPr>
               <a:t>4</a:t>
@@ -19230,11 +19266,11 @@
             </a:avLst>
           </a:prstGeom>
           <a:solidFill>
-            <a:srgbClr val="1F3A5F"/>
+            <a:srgbClr val="333333"/>
           </a:solidFill>
           <a:ln w="12700">
             <a:solidFill>
-              <a:srgbClr val="1F3A5F"/>
+              <a:srgbClr val="333333"/>
             </a:solidFill>
             <a:prstDash val="solid"/>
           </a:ln>
@@ -19255,11 +19291,11 @@
             <a:avLst/>
           </a:prstGeom>
           <a:solidFill>
-            <a:srgbClr val="D9931D"/>
+            <a:srgbClr val="A6A6A6"/>
           </a:solidFill>
           <a:ln w="12700">
             <a:solidFill>
-              <a:srgbClr val="D9931D"/>
+              <a:srgbClr val="A6A6A6"/>
             </a:solidFill>
             <a:prstDash val="solid"/>
           </a:ln>
@@ -19292,7 +19328,7 @@
             <a:r>
               <a:rPr lang="en-US" sz="1400" b="1" dirty="0">
                 <a:solidFill>
-                  <a:schemeClr val="bg1"/>
+                  <a:srgbClr val="000000"/>
                 </a:solidFill>
               </a:rPr>
               <a:t>5</a:t>
@@ -19403,7 +19439,7 @@
             <a:lvl1pPr>
               <a:defRPr sz="1000">
                 <a:solidFill>
-                  <a:srgbClr val="9BA7B4"/>
+                  <a:srgbClr val="BFBFBF"/>
                 </a:solidFill>
               </a:defRPr>
             </a:lvl1pPr>
@@ -19498,7 +19534,7 @@
           <a:noFill/>
           <a:ln w="25400">
             <a:solidFill>
-              <a:srgbClr val="9BA7B4"/>
+              <a:srgbClr val="BFBFBF"/>
             </a:solidFill>
             <a:prstDash val="solid"/>
           </a:ln>
@@ -19519,7 +19555,7 @@
             <a:avLst/>
           </a:prstGeom>
           <a:solidFill>
-            <a:srgbClr val="4A6670"/>
+            <a:srgbClr val="595959"/>
           </a:solidFill>
           <a:ln w="25400">
             <a:solidFill>
@@ -19582,11 +19618,11 @@
             </a:avLst>
           </a:prstGeom>
           <a:solidFill>
-            <a:srgbClr val="EEF3F8"/>
+            <a:srgbClr val="EDEDED"/>
           </a:solidFill>
           <a:ln w="12700">
             <a:solidFill>
-              <a:srgbClr val="EEF3F8"/>
+              <a:srgbClr val="EDEDED"/>
             </a:solidFill>
             <a:prstDash val="solid"/>
           </a:ln>
@@ -19679,7 +19715,7 @@
             <a:avLst/>
           </a:prstGeom>
           <a:solidFill>
-            <a:srgbClr val="5B7DB1"/>
+            <a:srgbClr val="737373"/>
           </a:solidFill>
           <a:ln w="25400">
             <a:solidFill>
@@ -19742,11 +19778,11 @@
             </a:avLst>
           </a:prstGeom>
           <a:solidFill>
-            <a:srgbClr val="EEF3F8"/>
+            <a:srgbClr val="EDEDED"/>
           </a:solidFill>
           <a:ln w="12700">
             <a:solidFill>
-              <a:srgbClr val="EEF3F8"/>
+              <a:srgbClr val="EDEDED"/>
             </a:solidFill>
             <a:prstDash val="solid"/>
           </a:ln>
@@ -19839,7 +19875,7 @@
             <a:avLst/>
           </a:prstGeom>
           <a:solidFill>
-            <a:srgbClr val="0E7C86"/>
+            <a:srgbClr val="404040"/>
           </a:solidFill>
           <a:ln w="25400">
             <a:solidFill>
@@ -19902,11 +19938,11 @@
             </a:avLst>
           </a:prstGeom>
           <a:solidFill>
-            <a:srgbClr val="EEF3F8"/>
+            <a:srgbClr val="EDEDED"/>
           </a:solidFill>
           <a:ln w="12700">
             <a:solidFill>
-              <a:srgbClr val="EEF3F8"/>
+              <a:srgbClr val="EDEDED"/>
             </a:solidFill>
             <a:prstDash val="solid"/>
           </a:ln>
@@ -19999,7 +20035,7 @@
             <a:avLst/>
           </a:prstGeom>
           <a:solidFill>
-            <a:srgbClr val="D9931D"/>
+            <a:srgbClr val="A6A6A6"/>
           </a:solidFill>
           <a:ln w="25400">
             <a:solidFill>
@@ -20062,11 +20098,11 @@
             </a:avLst>
           </a:prstGeom>
           <a:solidFill>
-            <a:srgbClr val="EEF3F8"/>
+            <a:srgbClr val="EDEDED"/>
           </a:solidFill>
           <a:ln w="12700">
             <a:solidFill>
-              <a:srgbClr val="EEF3F8"/>
+              <a:srgbClr val="EDEDED"/>
             </a:solidFill>
             <a:prstDash val="solid"/>
           </a:ln>
@@ -20174,7 +20210,7 @@
             <a:lvl1pPr>
               <a:defRPr sz="1000">
                 <a:solidFill>
-                  <a:srgbClr val="4A6670"/>
+                  <a:srgbClr val="595959"/>
                 </a:solidFill>
               </a:defRPr>
             </a:lvl1pPr>
@@ -20343,7 +20379,7 @@
                       <a:tailEnd type="none" w="med" len="med"/>
                     </a:lnB>
                     <a:solidFill>
-                      <a:srgbClr val="1F3A5F"/>
+                      <a:srgbClr val="333333"/>
                     </a:solidFill>
                   </a:tcPr>
                 </a:tc>
@@ -20358,7 +20394,7 @@
                       <a:r>
                         <a:rPr lang="en-US" sz="1300" dirty="0">
                           <a:solidFill>
-                            <a:srgbClr val="1B1F2E"/>
+                            <a:srgbClr val="000000"/>
                           </a:solidFill>
                           <a:latin typeface="Calibri" pitchFamily="34" charset="0"/>
                           <a:ea typeface="Calibri" pitchFamily="34" charset="-122"/>
@@ -20411,7 +20447,7 @@
                       <a:tailEnd type="none" w="med" len="med"/>
                     </a:lnB>
                     <a:solidFill>
-                      <a:srgbClr val="EEF3F8"/>
+                      <a:srgbClr val="EDEDED"/>
                     </a:solidFill>
                   </a:tcPr>
                 </a:tc>
@@ -20481,7 +20517,7 @@
                       <a:tailEnd type="none" w="med" len="med"/>
                     </a:lnB>
                     <a:solidFill>
-                      <a:srgbClr val="1F3A5F"/>
+                      <a:srgbClr val="333333"/>
                     </a:solidFill>
                   </a:tcPr>
                 </a:tc>
@@ -20496,7 +20532,7 @@
                       <a:r>
                         <a:rPr lang="en-US" sz="1300" dirty="0">
                           <a:solidFill>
-                            <a:srgbClr val="1B1F2E"/>
+                            <a:srgbClr val="000000"/>
                           </a:solidFill>
                           <a:latin typeface="Calibri" pitchFamily="34" charset="0"/>
                           <a:ea typeface="Calibri" pitchFamily="34" charset="-122"/>
@@ -20549,7 +20585,7 @@
                       <a:tailEnd type="none" w="med" len="med"/>
                     </a:lnB>
                     <a:solidFill>
-                      <a:srgbClr val="EEF3F8"/>
+                      <a:srgbClr val="EDEDED"/>
                     </a:solidFill>
                   </a:tcPr>
                 </a:tc>
@@ -20619,7 +20655,7 @@
                       <a:tailEnd type="none" w="med" len="med"/>
                     </a:lnB>
                     <a:solidFill>
-                      <a:srgbClr val="1F3A5F"/>
+                      <a:srgbClr val="333333"/>
                     </a:solidFill>
                   </a:tcPr>
                 </a:tc>
@@ -20634,7 +20670,7 @@
                       <a:r>
                         <a:rPr lang="en-US" sz="1300" dirty="0">
                           <a:solidFill>
-                            <a:srgbClr val="1B1F2E"/>
+                            <a:srgbClr val="000000"/>
                           </a:solidFill>
                           <a:latin typeface="Calibri" pitchFamily="34" charset="0"/>
                           <a:ea typeface="Calibri" pitchFamily="34" charset="-122"/>
@@ -20687,7 +20723,7 @@
                       <a:tailEnd type="none" w="med" len="med"/>
                     </a:lnB>
                     <a:solidFill>
-                      <a:srgbClr val="EEF3F8"/>
+                      <a:srgbClr val="EDEDED"/>
                     </a:solidFill>
                   </a:tcPr>
                 </a:tc>
@@ -20757,7 +20793,7 @@
                       <a:tailEnd type="none" w="med" len="med"/>
                     </a:lnB>
                     <a:solidFill>
-                      <a:srgbClr val="1F3A5F"/>
+                      <a:srgbClr val="333333"/>
                     </a:solidFill>
                   </a:tcPr>
                 </a:tc>
@@ -20772,7 +20808,7 @@
                       <a:r>
                         <a:rPr lang="en-US" sz="1300" dirty="0">
                           <a:solidFill>
-                            <a:srgbClr val="1B1F2E"/>
+                            <a:srgbClr val="000000"/>
                           </a:solidFill>
                           <a:latin typeface="Calibri" pitchFamily="34" charset="0"/>
                           <a:ea typeface="Calibri" pitchFamily="34" charset="-122"/>
@@ -20825,7 +20861,7 @@
                       <a:tailEnd type="none" w="med" len="med"/>
                     </a:lnB>
                     <a:solidFill>
-                      <a:srgbClr val="EEF3F8"/>
+                      <a:srgbClr val="EDEDED"/>
                     </a:solidFill>
                   </a:tcPr>
                 </a:tc>
@@ -20895,7 +20931,7 @@
                       <a:tailEnd type="none" w="med" len="med"/>
                     </a:lnB>
                     <a:solidFill>
-                      <a:srgbClr val="1F3A5F"/>
+                      <a:srgbClr val="333333"/>
                     </a:solidFill>
                   </a:tcPr>
                 </a:tc>
@@ -20910,7 +20946,7 @@
                       <a:r>
                         <a:rPr lang="en-US" sz="1300" dirty="0">
                           <a:solidFill>
-                            <a:srgbClr val="1B1F2E"/>
+                            <a:srgbClr val="000000"/>
                           </a:solidFill>
                           <a:latin typeface="Calibri" pitchFamily="34" charset="0"/>
                           <a:ea typeface="Calibri" pitchFamily="34" charset="-122"/>
@@ -20963,7 +20999,7 @@
                       <a:tailEnd type="none" w="med" len="med"/>
                     </a:lnB>
                     <a:solidFill>
-                      <a:srgbClr val="EEF3F8"/>
+                      <a:srgbClr val="EDEDED"/>
                     </a:solidFill>
                   </a:tcPr>
                 </a:tc>
@@ -21033,7 +21069,7 @@
                       <a:tailEnd type="none" w="med" len="med"/>
                     </a:lnB>
                     <a:solidFill>
-                      <a:srgbClr val="1F3A5F"/>
+                      <a:srgbClr val="333333"/>
                     </a:solidFill>
                   </a:tcPr>
                 </a:tc>
@@ -21048,7 +21084,7 @@
                       <a:r>
                         <a:rPr lang="en-US" sz="1300" dirty="0">
                           <a:solidFill>
-                            <a:srgbClr val="1B1F2E"/>
+                            <a:srgbClr val="000000"/>
                           </a:solidFill>
                           <a:latin typeface="Calibri" pitchFamily="34" charset="0"/>
                           <a:ea typeface="Calibri" pitchFamily="34" charset="-122"/>
@@ -21101,7 +21137,7 @@
                       <a:tailEnd type="none" w="med" len="med"/>
                     </a:lnB>
                     <a:solidFill>
-                      <a:srgbClr val="EEF3F8"/>
+                      <a:srgbClr val="EDEDED"/>
                     </a:solidFill>
                   </a:tcPr>
                 </a:tc>
@@ -21171,7 +21207,7 @@
                       <a:tailEnd type="none" w="med" len="med"/>
                     </a:lnB>
                     <a:solidFill>
-                      <a:srgbClr val="1F3A5F"/>
+                      <a:srgbClr val="333333"/>
                     </a:solidFill>
                   </a:tcPr>
                 </a:tc>
@@ -21186,7 +21222,7 @@
                       <a:r>
                         <a:rPr lang="en-US" sz="1300" dirty="0">
                           <a:solidFill>
-                            <a:srgbClr val="1B1F2E"/>
+                            <a:srgbClr val="000000"/>
                           </a:solidFill>
                           <a:latin typeface="Calibri" pitchFamily="34" charset="0"/>
                           <a:ea typeface="Calibri" pitchFamily="34" charset="-122"/>
@@ -21239,7 +21275,7 @@
                       <a:tailEnd type="none" w="med" len="med"/>
                     </a:lnB>
                     <a:solidFill>
-                      <a:srgbClr val="EEF3F8"/>
+                      <a:srgbClr val="EDEDED"/>
                     </a:solidFill>
                   </a:tcPr>
                 </a:tc>
@@ -21309,7 +21345,7 @@
                       <a:tailEnd type="none" w="med" len="med"/>
                     </a:lnB>
                     <a:solidFill>
-                      <a:srgbClr val="1F3A5F"/>
+                      <a:srgbClr val="333333"/>
                     </a:solidFill>
                   </a:tcPr>
                 </a:tc>
@@ -21324,7 +21360,7 @@
                       <a:r>
                         <a:rPr lang="en-US" sz="1300" dirty="0">
                           <a:solidFill>
-                            <a:srgbClr val="1B1F2E"/>
+                            <a:srgbClr val="000000"/>
                           </a:solidFill>
                           <a:latin typeface="Calibri" pitchFamily="34" charset="0"/>
                           <a:ea typeface="Calibri" pitchFamily="34" charset="-122"/>
@@ -21377,7 +21413,7 @@
                       <a:tailEnd type="none" w="med" len="med"/>
                     </a:lnB>
                     <a:solidFill>
-                      <a:srgbClr val="EEF3F8"/>
+                      <a:srgbClr val="EDEDED"/>
                     </a:solidFill>
                   </a:tcPr>
                 </a:tc>
@@ -21416,7 +21452,7 @@
             <a:lvl1pPr>
               <a:defRPr sz="1000">
                 <a:solidFill>
-                  <a:srgbClr val="4A6670"/>
+                  <a:srgbClr val="595959"/>
                 </a:solidFill>
               </a:defRPr>
             </a:lvl1pPr>
@@ -21440,47 +21476,47 @@
 </file>
 
 <file path=ppt/theme/theme1.xml><?xml version="1.0" encoding="utf-8"?>
-<a:theme xmlns:a="http://schemas.openxmlformats.org/drawingml/2006/main" name="Derecho Informatico UFPS">
+<a:theme xmlns:a="http://schemas.openxmlformats.org/drawingml/2006/main" name="Derecho Informatico UFPS BN">
   <a:themeElements>
-    <a:clrScheme name="Derecho Informatico UFPS">
+    <a:clrScheme name="Derecho Informatico UFPS BN">
       <a:dk1>
-        <a:srgbClr val="1B1F2E"/>
+        <a:srgbClr val="000000"/>
       </a:dk1>
       <a:lt1>
         <a:srgbClr val="FFFFFF"/>
       </a:lt1>
       <a:dk2>
-        <a:srgbClr val="1F3A5F"/>
+        <a:srgbClr val="333333"/>
       </a:dk2>
       <a:lt2>
-        <a:srgbClr val="EEF3F8"/>
+        <a:srgbClr val="EDEDED"/>
       </a:lt2>
       <a:accent1>
-        <a:srgbClr val="0E7C86"/>
+        <a:srgbClr val="404040"/>
       </a:accent1>
       <a:accent2>
-        <a:srgbClr val="D9931D"/>
+        <a:srgbClr val="A6A6A6"/>
       </a:accent2>
       <a:accent3>
-        <a:srgbClr val="5B7DB1"/>
+        <a:srgbClr val="737373"/>
       </a:accent3>
       <a:accent4>
-        <a:srgbClr val="B5413F"/>
+        <a:srgbClr val="4D4D4D"/>
       </a:accent4>
       <a:accent5>
-        <a:srgbClr val="4A6670"/>
+        <a:srgbClr val="595959"/>
       </a:accent5>
       <a:accent6>
-        <a:srgbClr val="9BA7B4"/>
+        <a:srgbClr val="BFBFBF"/>
       </a:accent6>
       <a:hlink>
-        <a:srgbClr val="0E7C86"/>
+        <a:srgbClr val="404040"/>
       </a:hlink>
       <a:folHlink>
-        <a:srgbClr val="5B7DB1"/>
+        <a:srgbClr val="666666"/>
       </a:folHlink>
     </a:clrScheme>
-    <a:fontScheme name="Derecho Informatico UFPS">
+    <a:fontScheme name="Derecho Informatico UFPS BN">
       <a:majorFont>
         <a:latin typeface="Cambria"/>
         <a:ea typeface=""/>

</xml_diff>